<commit_message>
docs(slides): rewrite Life Manager deck in plain Japanese
</commit_message>
<xml_diff>
--- a/docs/slides/life-manager-lt-2026-07-28/life-manager-lt-ja-2026-07-28.pptx
+++ b/docs/slides/life-manager-lt-2026-07-28/life-manager-lt-ja-2026-07-28.pptx
@@ -515,7 +515,7 @@
           <a:p>
             <a:r>
               <a:rPr lang="en-US" dirty="0"/>
-              <a:t>導入。今日は、Life Managerを「何を作っているか」「どこまでできたか」「何が残っているか」の順に話す。</a:t>
+              <a:t>今日は、Life Managerで何を任せられるようにしたいのか、いま何が動いていて、何が残っているのかを話す。</a:t>
             </a:r>
             <a:endParaRPr lang="en-US" dirty="0"/>
           </a:p>
@@ -603,7 +603,7 @@
           <a:p>
             <a:r>
               <a:rPr lang="en-US" dirty="0"/>
-              <a:t>今日のライブ状況。CodexのLife Managerスレッドはactive。ローカル正本のカーソルは8iだが、ライブスレッドはより新しいH3/H5等のキューを処理中。push前の差を混同しない。</a:t>
+              <a:t>GitHubで確認できる正本は8i。別のCodexスレッドでは、その先の作業も進んでいる。ただし、未pushや別ブランチの作業は完了扱いにしない。</a:t>
             </a:r>
             <a:endParaRPr lang="en-US" dirty="0"/>
           </a:p>
@@ -691,7 +691,7 @@
           <a:p>
             <a:r>
               <a:rPr lang="en-US" dirty="0"/>
-              <a:t>正本の残TODOをフェーズで示す。目先は統合。次に獲得と自己修復。最後に各臓器を完成させる。</a:t>
+              <a:t>残作業はこの順番で進める。まずリポジトリを一本化し、集客と開発の自動修復を作る。その後、健康、心、お金の機能を仕上げる。</a:t>
             </a:r>
             <a:endParaRPr lang="en-US" dirty="0"/>
           </a:p>
@@ -779,7 +779,7 @@
           <a:p>
             <a:r>
               <a:rPr lang="en-US" dirty="0"/>
-              <a:t>自律性は無制限な自由ではない。委任範囲、可逆性、コスト、リスク、証拠でゲートする。質問を減らすことと、嘘をつかないことを両立する。</a:t>
+              <a:t>任せた範囲では、実行してから報告する。権限は必要な分だけ受け取り、実行結果は録音やMessage-IDなどで確認する。失敗も隠さない。</a:t>
             </a:r>
             <a:endParaRPr lang="en-US" dirty="0"/>
           </a:p>
@@ -867,7 +867,7 @@
           <a:p>
             <a:r>
               <a:rPr lang="en-US" dirty="0"/>
-              <a:t>長期ビジョン。AIが外部経済から収益を得て、自分の計算資源を払い、ユーザー負担を下げる。これは現状では北極星であり、実績と分けて語る。</a:t>
+              <a:t>長期目標は、AIが仕事で収入を得て、自分のモデル代とサーバー代を払うこと。残りを本人へ送り、利用料を下げる。まだ実績ではなく、今後作る部分。</a:t>
             </a:r>
             <a:endParaRPr lang="en-US" dirty="0"/>
           </a:p>
@@ -955,7 +955,7 @@
           <a:p>
             <a:r>
               <a:rPr lang="en-US" dirty="0"/>
-              <a:t>締め。Life ManagerはUIではなく、生活を観測し、行動し、実証し、学ぶオペレーター。</a:t>
+              <a:t>Life Managerは、予定と場所を読み、必要な処理を実行し、結果を本人へ伝える。失敗したら原因を調べて直す。そこまでを任せたい。</a:t>
             </a:r>
             <a:endParaRPr lang="en-US" dirty="0"/>
           </a:p>
@@ -1043,7 +1043,7 @@
           <a:p>
             <a:r>
               <a:rPr lang="en-US" dirty="0"/>
-              <a:t>Life Managerが解く問題は、アプリ不足ではない。人間の頭が、予定・移動・連絡・健康・収入のオペレーターになっていること。</a:t>
+              <a:t>自分は、次の予定、出発時刻、予約、連絡をずっと気にしている。小さな用事でも、忘れないように抱えているだけで疲れる。</a:t>
             </a:r>
             <a:endParaRPr lang="en-US" dirty="0"/>
           </a:p>
@@ -1131,7 +1131,7 @@
           <a:p>
             <a:r>
               <a:rPr lang="en-US" dirty="0"/>
-              <a:t>北極星。Life Managerは三つの臓器を持つ。財務・身体・精神を別々のアプリで管理するのではなく、一つの文脈から動かす。</a:t>
+              <a:t>Life Managerには、身体、心、お金の用事を任せたい。予定、場所、本人の希望をまとめて見て、次に片づけることを決める。</a:t>
             </a:r>
             <a:endParaRPr lang="en-US" dirty="0"/>
           </a:p>
@@ -1219,7 +1219,7 @@
           <a:p>
             <a:r>
               <a:rPr lang="en-US" dirty="0"/>
-              <a:t>制作方法そのものも実験。私はPCの前に座らず、ChatGPTのiPhoneアプリからMac mini上のCodexへ指示し、コード・テスト・デプロイまで進めている。</a:t>
+              <a:t>開発の指示はChatGPTのiPhoneアプリから出している。Mac miniに接続したCodexがコードを読み、作り、試し、GitHubへ残す。</a:t>
             </a:r>
             <a:endParaRPr lang="en-US" dirty="0"/>
           </a:p>
@@ -1307,7 +1307,7 @@
           <a:p>
             <a:r>
               <a:rPr lang="en-US" dirty="0"/>
-              <a:t>DAILY organの理想体験。ユーザーが開く画面より、向こうから来る電話と報告が主UI。</a:t>
+              <a:t>本人は予定を入れる。Life Managerは移動時間を足し、必要なら電話し、遅刻の連絡を送り、最後にTelegramで結果を知らせる。</a:t>
             </a:r>
             <a:endParaRPr lang="en-US" dirty="0"/>
           </a:p>
@@ -1395,7 +1395,7 @@
           <a:p>
             <a:r>
               <a:rPr lang="en-US" dirty="0"/>
-              <a:t>完成済みと本番実証済みを分けない。正本では、DAILY核・電話・パネル認証・スコア・プライバシーがproduction L3済み。</a:t>
+              <a:t>予定、電話、個人パネル、設定、結果の集計、画面の安全対策は、本番で実物を使って確認した。APIが成功を返しただけでは完了にしていない。</a:t>
             </a:r>
             <a:endParaRPr lang="en-US" dirty="0"/>
           </a:p>
@@ -1483,7 +1483,7 @@
           <a:p>
             <a:r>
               <a:rPr lang="en-US" dirty="0"/>
-              <a:t>システム構造。頭脳の下に三臓器、共有実行基盤、外部世界がある。チャネルはambient first。</a:t>
+              <a:t>本人の希望、予定、場所、許可、予算、過去の結果を見て、健康、心、お金のどれを処理するか決める。実行にはブラウザ、メール、電話などを使う。</a:t>
             </a:r>
             <a:endParaRPr lang="en-US" dirty="0"/>
           </a:p>
@@ -1571,7 +1571,7 @@
           <a:p>
             <a:r>
               <a:rPr lang="en-US" dirty="0"/>
-              <a:t>ユーザー体験はambient first。パネルは主役ではなく、鏡とコントロールセンター。</a:t>
+              <a:t>普段の連絡は電話とTelegramで受け取る。個人パネルは毎日開く画面ではなく、設定を変えたり、実行結果を確かめたりするときに使う。</a:t>
             </a:r>
             <a:endParaRPr lang="en-US" dirty="0"/>
           </a:p>
@@ -1659,7 +1659,7 @@
           <a:p>
             <a:r>
               <a:rPr lang="en-US" dirty="0"/>
-              <a:t>自己改善の核はループ。観測、評価、行動、実世界検証、学習。失敗時は黙らず、止めて修復し、同じ失敗をテストに変える。</a:t>
+              <a:t>ログと数値から失敗を見つけ、原因を調べ、コードを直し、本物の電話やメールで確認する。同じ失敗はテストに残す。</a:t>
             </a:r>
             <a:endParaRPr lang="en-US" dirty="0"/>
           </a:p>
@@ -2083,7 +2083,7 @@
         <p:spPr>
           <a:xfrm>
             <a:off x="685800" y="1066800"/>
-            <a:ext cx="6995160" cy="1398984"/>
+            <a:ext cx="6995160" cy="2098477"/>
           </a:xfrm>
           <a:prstGeom prst="rect">
             <a:avLst/>
@@ -2113,7 +2113,7 @@
                 <a:ea typeface="Arial" pitchFamily="34" charset="-122"/>
                 <a:cs typeface="Arial" pitchFamily="34" charset="-120"/>
               </a:rPr>
-              <a:t>理想の生活が
+              <a:t>予定も連絡も、
 </a:t>
             </a:r>
             <a:pPr algn="l" indent="0" marL="0">
@@ -2134,7 +2134,7 @@
                 <a:ea typeface="Arial" pitchFamily="34" charset="-122"/>
                 <a:cs typeface="Arial" pitchFamily="34" charset="-120"/>
               </a:rPr>
-              <a:t>向こうから来る。</a:t>
+              <a:t>先回りして終わらせる。</a:t>
             </a:r>
             <a:endParaRPr lang="en-US" sz="5100" dirty="0"/>
           </a:p>
@@ -2148,7 +2148,7 @@
         </p:nvSpPr>
         <p:spPr>
           <a:xfrm>
-            <a:off x="685800" y="2732484"/>
+            <a:off x="685800" y="3431977"/>
             <a:ext cx="6315075" cy="666750"/>
           </a:xfrm>
           <a:prstGeom prst="rect">
@@ -2179,7 +2179,7 @@
                 <a:ea typeface="Arial" pitchFamily="34" charset="-122"/>
                 <a:cs typeface="Arial" pitchFamily="34" charset="-120"/>
               </a:rPr>
-              <a:t>1人・1台のスマホから、財務・身体・精神を動かす生活OSをつくる</a:t>
+              <a:t>スマホから指示を出し、Life Managerが予定、健康、お金の用事を片づける</a:t>
             </a:r>
             <a:endParaRPr lang="en-US" sz="1875" dirty="0"/>
           </a:p>
@@ -2848,7 +2848,7 @@
                 <a:ea typeface="Arial" pitchFamily="34" charset="-122"/>
                 <a:cs typeface="Arial" pitchFamily="34" charset="-120"/>
               </a:rPr>
-              <a:t>LIVE STATUS / 2026-07-28</a:t>
+              <a:t>進行中の作業 / 2026-07-28</a:t>
             </a:r>
             <a:endParaRPr lang="en-US" sz="1200" dirty="0"/>
           </a:p>
@@ -2893,7 +2893,7 @@
                 <a:ea typeface="Arial" pitchFamily="34" charset="-122"/>
                 <a:cs typeface="Arial" pitchFamily="34" charset="-120"/>
               </a:rPr>
-              <a:t>別のLife Managerエージェントは、</a:t>
+              <a:t>別のCodexスレッドで、</a:t>
             </a:r>
             <a:pPr algn="l" indent="0" marL="0">
               <a:lnSpc>
@@ -2913,7 +2913,7 @@
                 <a:ea typeface="Arial" pitchFamily="34" charset="-122"/>
                 <a:cs typeface="Arial" pitchFamily="34" charset="-120"/>
               </a:rPr>
-              <a:t>現在も稼働中</a:t>
+              <a:t>開発は続いている</a:t>
             </a:r>
             <a:endParaRPr lang="en-US" sz="3600" dirty="0"/>
           </a:p>
@@ -2994,7 +2994,7 @@
         <p:spPr>
           <a:xfrm>
             <a:off x="923925" y="2105025"/>
-            <a:ext cx="1738610" cy="304800"/>
+            <a:ext cx="1304032" cy="304800"/>
           </a:xfrm>
           <a:prstGeom prst="roundRect">
             <a:avLst>
@@ -3028,7 +3028,7 @@
         <p:spPr>
           <a:xfrm>
             <a:off x="1057275" y="2190750"/>
-            <a:ext cx="1501348" cy="133350"/>
+            <a:ext cx="1058079" cy="133350"/>
           </a:xfrm>
           <a:prstGeom prst="rect">
             <a:avLst/>
@@ -3055,7 +3055,7 @@
                 <a:ea typeface="Arial" pitchFamily="34" charset="-122"/>
                 <a:cs typeface="Arial" pitchFamily="34" charset="-120"/>
               </a:rPr>
-              <a:t>LOCAL SSOT CURSOR</a:t>
+              <a:t>PUSH済みの正本</a:t>
             </a:r>
             <a:endParaRPr lang="en-US" sz="1050" dirty="0"/>
           </a:p>
@@ -3145,7 +3145,7 @@
                 <a:ea typeface="Arial" pitchFamily="34" charset="-122"/>
                 <a:cs typeface="Arial" pitchFamily="34" charset="-120"/>
               </a:rPr>
-              <a:t>ONE-REPO 統合</a:t>
+              <a:t>リポジトリ統合</a:t>
             </a:r>
             <a:endParaRPr lang="en-US" sz="1875" dirty="0"/>
           </a:p>
@@ -3258,7 +3258,7 @@
                 <a:ea typeface="Arial" pitchFamily="34" charset="-122"/>
                 <a:cs typeface="Arial" pitchFamily="34" charset="-120"/>
               </a:rPr>
-              <a:t>push済み正本で確認した位置</a:t>
+              <a:t>GitHubで確認した位置</a:t>
             </a:r>
             <a:endParaRPr lang="en-US" sz="1275" dirty="0"/>
           </a:p>
@@ -3309,7 +3309,7 @@
         <p:spPr>
           <a:xfrm>
             <a:off x="5229225" y="2105025"/>
-            <a:ext cx="1899196" cy="304800"/>
+            <a:ext cx="1807815" cy="304800"/>
           </a:xfrm>
           <a:prstGeom prst="roundRect">
             <a:avLst>
@@ -3343,7 +3343,7 @@
         <p:spPr>
           <a:xfrm>
             <a:off x="5362575" y="2190750"/>
-            <a:ext cx="1665146" cy="133350"/>
+            <a:ext cx="1571938" cy="133350"/>
           </a:xfrm>
           <a:prstGeom prst="rect">
             <a:avLst/>
@@ -3370,7 +3370,7 @@
                 <a:ea typeface="Arial" pitchFamily="34" charset="-122"/>
                 <a:cs typeface="Arial" pitchFamily="34" charset="-120"/>
               </a:rPr>
-              <a:t>CODEX THREAD: ACTIVE</a:t>
+              <a:t>CODEXスレッド：稼働中</a:t>
             </a:r>
             <a:endParaRPr lang="en-US" sz="1050" dirty="0"/>
           </a:p>
@@ -3384,8 +3384,8 @@
         </p:nvSpPr>
         <p:spPr>
           <a:xfrm>
-            <a:off x="10529739" y="2148185"/>
-            <a:ext cx="753103" cy="218480"/>
+            <a:off x="10458450" y="2148185"/>
+            <a:ext cx="825818" cy="218480"/>
           </a:xfrm>
           <a:prstGeom prst="rect">
             <a:avLst/>
@@ -3412,7 +3412,7 @@
                 <a:ea typeface="Arial" pitchFamily="34" charset="-122"/>
                 <a:cs typeface="Arial" pitchFamily="34" charset="-120"/>
               </a:rPr>
-              <a:t>live queue</a:t>
+              <a:t>いま処理中</a:t>
             </a:r>
             <a:endParaRPr lang="en-US" sz="1275" dirty="0"/>
           </a:p>
@@ -3535,7 +3535,7 @@
                 <a:ea typeface="Arial" pitchFamily="34" charset="-122"/>
                 <a:cs typeface="Arial" pitchFamily="34" charset="-120"/>
               </a:rPr>
-              <a:t>checkup spec → builder</a:t>
+              <a:t>健康診断の仕様 → 実装</a:t>
             </a:r>
             <a:endParaRPr lang="en-US" sz="1500" dirty="0"/>
           </a:p>
@@ -3658,7 +3658,7 @@
                 <a:ea typeface="Arial" pitchFamily="34" charset="-122"/>
                 <a:cs typeface="Arial" pitchFamily="34" charset="-120"/>
               </a:rPr>
-              <a:t>relations</a:t>
+              <a:t>人間関係</a:t>
             </a:r>
             <a:endParaRPr lang="en-US" sz="1500" dirty="0"/>
           </a:p>
@@ -3781,7 +3781,7 @@
                 <a:ea typeface="Arial" pitchFamily="34" charset="-122"/>
                 <a:cs typeface="Arial" pitchFamily="34" charset="-120"/>
               </a:rPr>
-              <a:t>Day 2–7 / self-build台帳</a:t>
+              <a:t>2〜7日目の収益台帳</a:t>
             </a:r>
             <a:endParaRPr lang="en-US" sz="1500" dirty="0"/>
           </a:p>
@@ -3904,7 +3904,7 @@
                 <a:ea typeface="Arial" pitchFamily="34" charset="-122"/>
                 <a:cs typeface="Arial" pitchFamily="34" charset="-120"/>
               </a:rPr>
-              <a:t>scan → 11b → 11c</a:t>
+              <a:t>検知 → 候補 → 予約</a:t>
             </a:r>
             <a:endParaRPr lang="en-US" sz="1500" dirty="0"/>
           </a:p>
@@ -3982,7 +3982,7 @@
                 <a:ea typeface="Arial" pitchFamily="34" charset="-122"/>
                 <a:cs typeface="Arial" pitchFamily="34" charset="-120"/>
               </a:rPr>
-              <a:t>OPS</a:t>
+              <a:t>運用</a:t>
             </a:r>
             <a:endParaRPr lang="en-US" sz="1275" dirty="0"/>
           </a:p>
@@ -4027,7 +4027,7 @@
                 <a:ea typeface="Arial" pitchFamily="34" charset="-122"/>
                 <a:cs typeface="Arial" pitchFamily="34" charset="-120"/>
               </a:rPr>
-              <a:t>diet / precepts 初配信</a:t>
+              <a:t>食事 / 戒律 初回配信</a:t>
             </a:r>
             <a:endParaRPr lang="en-US" sz="1500" dirty="0"/>
           </a:p>
@@ -4150,7 +4150,7 @@
                 <a:ea typeface="Arial" pitchFamily="34" charset="-122"/>
                 <a:cs typeface="Arial" pitchFamily="34" charset="-120"/>
               </a:rPr>
-              <a:t>残高の自動回復</a:t>
+              <a:t>残高の自動補充</a:t>
             </a:r>
             <a:endParaRPr lang="en-US" sz="1500" dirty="0"/>
           </a:p>
@@ -4165,7 +4165,7 @@
         <p:spPr>
           <a:xfrm>
             <a:off x="685800" y="5762625"/>
-            <a:ext cx="7111898" cy="218480"/>
+            <a:ext cx="5478328" cy="218480"/>
           </a:xfrm>
           <a:prstGeom prst="rect">
             <a:avLst/>
@@ -4192,7 +4192,7 @@
                 <a:ea typeface="Arial" pitchFamily="34" charset="-122"/>
                 <a:cs typeface="Arial" pitchFamily="34" charset="-120"/>
               </a:rPr>
-              <a:t>この差は「未push / 別branchのライブ作業」を正本完了と誤認しないため、意図的に分離表示。</a:t>
+              <a:t>右側には未pushや別ブランチの作業も含む。ここでは完了扱いにしない。</a:t>
             </a:r>
             <a:endParaRPr lang="en-US" sz="1275" dirty="0"/>
           </a:p>
@@ -4350,7 +4350,7 @@
                 <a:ea typeface="Arial" pitchFamily="34" charset="-122"/>
                 <a:cs typeface="Arial" pitchFamily="34" charset="-120"/>
               </a:rPr>
-              <a:t>REMAINING ROADMAP</a:t>
+              <a:t>残作業</a:t>
             </a:r>
             <a:endParaRPr lang="en-US" sz="1200" dirty="0"/>
           </a:p>
@@ -4387,15 +4387,15 @@
               <a:buNone/>
             </a:pPr>
             <a:r>
-              <a:rPr lang="en-US" sz="3600" dirty="0">
-                <a:solidFill>
-                  <a:srgbClr val="F7F4EA"/>
-                </a:solidFill>
-                <a:latin typeface="Arial" pitchFamily="34" charset="0"/>
-                <a:ea typeface="Arial" pitchFamily="34" charset="-122"/>
-                <a:cs typeface="Arial" pitchFamily="34" charset="-120"/>
-              </a:rPr>
-              <a:t>残りは、上から</a:t>
+              <a:rPr lang="en-US" sz="3600" b="1" dirty="0">
+                <a:solidFill>
+                  <a:srgbClr val="FFC857"/>
+                </a:solidFill>
+                <a:latin typeface="Arial" pitchFamily="34" charset="0"/>
+                <a:ea typeface="Arial" pitchFamily="34" charset="-122"/>
+                <a:cs typeface="Arial" pitchFamily="34" charset="-120"/>
+              </a:rPr>
+              <a:t>残っている作業</a:t>
             </a:r>
             <a:pPr algn="l" indent="0" marL="0">
               <a:lnSpc>
@@ -4407,15 +4407,15 @@
               <a:buNone/>
             </a:pPr>
             <a:r>
-              <a:rPr lang="en-US" sz="3600" b="1" dirty="0">
-                <a:solidFill>
-                  <a:srgbClr val="FFC857"/>
-                </a:solidFill>
-                <a:latin typeface="Arial" pitchFamily="34" charset="0"/>
-                <a:ea typeface="Arial" pitchFamily="34" charset="-122"/>
-                <a:cs typeface="Arial" pitchFamily="34" charset="-120"/>
-              </a:rPr>
-              <a:t>この順番</a:t>
+              <a:rPr lang="en-US" sz="3600" dirty="0">
+                <a:solidFill>
+                  <a:srgbClr val="F7F4EA"/>
+                </a:solidFill>
+                <a:latin typeface="Arial" pitchFamily="34" charset="0"/>
+                <a:ea typeface="Arial" pitchFamily="34" charset="-122"/>
+                <a:cs typeface="Arial" pitchFamily="34" charset="-120"/>
+              </a:rPr>
+              <a:t>と、その順番</a:t>
             </a:r>
             <a:endParaRPr lang="en-US" sz="3600" dirty="0"/>
           </a:p>
@@ -4611,7 +4611,7 @@
                 <a:ea typeface="Arial" pitchFamily="34" charset="-122"/>
                 <a:cs typeface="Arial" pitchFamily="34" charset="-120"/>
               </a:rPr>
-              <a:t>NOW</a:t>
+              <a:t>最優先</a:t>
             </a:r>
             <a:endParaRPr lang="en-US" sz="1275" dirty="0"/>
           </a:p>
@@ -4698,7 +4698,7 @@
                 <a:ea typeface="Arial" pitchFamily="34" charset="-122"/>
                 <a:cs typeface="Arial" pitchFamily="34" charset="-120"/>
               </a:rPr>
-              <a:t>ONE-REPO</a:t>
+              <a:t>リポジトリ統合</a:t>
             </a:r>
             <a:endParaRPr lang="en-US" sz="1500" dirty="0"/>
           </a:p>
@@ -4740,7 +4740,7 @@
                 <a:ea typeface="Arial" pitchFamily="34" charset="-122"/>
                 <a:cs typeface="Arial" pitchFamily="34" charset="-120"/>
               </a:rPr>
-              <a:t>repo・product・deployを一本化</a:t>
+              <a:t>正本・実装・配備先を一本化</a:t>
             </a:r>
             <a:endParaRPr lang="en-US" sz="1350" dirty="0"/>
           </a:p>
@@ -4906,7 +4906,7 @@
                 <a:ea typeface="Arial" pitchFamily="34" charset="-122"/>
                 <a:cs typeface="Arial" pitchFamily="34" charset="-120"/>
               </a:rPr>
-              <a:t>NEXT</a:t>
+              <a:t>その次</a:t>
             </a:r>
             <a:endParaRPr lang="en-US" sz="1275" dirty="0"/>
           </a:p>
@@ -4993,7 +4993,7 @@
                 <a:ea typeface="Arial" pitchFamily="34" charset="-122"/>
                 <a:cs typeface="Arial" pitchFamily="34" charset="-120"/>
               </a:rPr>
-              <a:t>MARKETING</a:t>
+              <a:t>集客</a:t>
             </a:r>
             <a:endParaRPr lang="en-US" sz="1500" dirty="0"/>
           </a:p>
@@ -5035,7 +5035,7 @@
                 <a:ea typeface="Arial" pitchFamily="34" charset="-122"/>
                 <a:cs typeface="Arial" pitchFamily="34" charset="-120"/>
               </a:rPr>
-              <a:t>動画生成→配信→計測→改善</a:t>
+              <a:t>動画作成→投稿→計測→修正</a:t>
             </a:r>
             <a:endParaRPr lang="en-US" sz="1350" dirty="0"/>
           </a:p>
@@ -5288,7 +5288,7 @@
                 <a:ea typeface="Arial" pitchFamily="34" charset="-122"/>
                 <a:cs typeface="Arial" pitchFamily="34" charset="-120"/>
               </a:rPr>
-              <a:t>DEV LOOP</a:t>
+              <a:t>開発の自動修復</a:t>
             </a:r>
             <a:endParaRPr lang="en-US" sz="1500" dirty="0"/>
           </a:p>
@@ -5330,7 +5330,7 @@
                 <a:ea typeface="Arial" pitchFamily="34" charset="-122"/>
                 <a:cs typeface="Arial" pitchFamily="34" charset="-120"/>
               </a:rPr>
-              <a:t>feedback/error→PR→自動修復</a:t>
+              <a:t>不具合→PR→配備→回復確認</a:t>
             </a:r>
             <a:endParaRPr lang="en-US" sz="1350" dirty="0"/>
           </a:p>
@@ -5583,7 +5583,7 @@
                 <a:ea typeface="Arial" pitchFamily="34" charset="-122"/>
                 <a:cs typeface="Arial" pitchFamily="34" charset="-120"/>
               </a:rPr>
-              <a:t>BRAIN</a:t>
+              <a:t>判断</a:t>
             </a:r>
             <a:endParaRPr lang="en-US" sz="1500" dirty="0"/>
           </a:p>
@@ -5625,7 +5625,7 @@
                 <a:ea typeface="Arial" pitchFamily="34" charset="-122"/>
                 <a:cs typeface="Arial" pitchFamily="34" charset="-120"/>
               </a:rPr>
-              <a:t>intent-aware context graph</a:t>
+              <a:t>予定と本人の意図から次を選ぶ</a:t>
             </a:r>
             <a:endParaRPr lang="en-US" sz="1350" dirty="0"/>
           </a:p>
@@ -5878,7 +5878,7 @@
                 <a:ea typeface="Arial" pitchFamily="34" charset="-122"/>
                 <a:cs typeface="Arial" pitchFamily="34" charset="-120"/>
               </a:rPr>
-              <a:t>PHYSICAL</a:t>
+              <a:t>健康</a:t>
             </a:r>
             <a:endParaRPr lang="en-US" sz="1500" dirty="0"/>
           </a:p>
@@ -6173,7 +6173,7 @@
                 <a:ea typeface="Arial" pitchFamily="34" charset="-122"/>
                 <a:cs typeface="Arial" pitchFamily="34" charset="-120"/>
               </a:rPr>
-              <a:t>MENTAL</a:t>
+              <a:t>心</a:t>
             </a:r>
             <a:endParaRPr lang="en-US" sz="1500" dirty="0"/>
           </a:p>
@@ -6215,7 +6215,7 @@
                 <a:ea typeface="Arial" pitchFamily="34" charset="-122"/>
                 <a:cs typeface="Arial" pitchFamily="34" charset="-120"/>
               </a:rPr>
-              <a:t>文脈駆動の介入</a:t>
+              <a:t>予定と場所に合わせて連絡</a:t>
             </a:r>
             <a:endParaRPr lang="en-US" sz="1350" dirty="0"/>
           </a:p>
@@ -6468,7 +6468,7 @@
                 <a:ea typeface="Arial" pitchFamily="34" charset="-122"/>
                 <a:cs typeface="Arial" pitchFamily="34" charset="-120"/>
               </a:rPr>
-              <a:t>FINANCIAL</a:t>
+              <a:t>お金</a:t>
             </a:r>
             <a:endParaRPr lang="en-US" sz="1500" dirty="0"/>
           </a:p>
@@ -6510,7 +6510,7 @@
                 <a:ea typeface="Arial" pitchFamily="34" charset="-122"/>
                 <a:cs typeface="Arial" pitchFamily="34" charset="-120"/>
               </a:rPr>
-              <a:t>wallet→収益→送金</a:t>
+              <a:t>収入→支払い→送金</a:t>
             </a:r>
             <a:endParaRPr lang="en-US" sz="1350" dirty="0"/>
           </a:p>
@@ -6676,7 +6676,7 @@
                 <a:ea typeface="Arial" pitchFamily="34" charset="-122"/>
                 <a:cs typeface="Arial" pitchFamily="34" charset="-120"/>
               </a:rPr>
-              <a:t>GATE</a:t>
+              <a:t>条件待ち</a:t>
             </a:r>
             <a:endParaRPr lang="en-US" sz="1275" dirty="0"/>
           </a:p>
@@ -6763,7 +6763,7 @@
                 <a:ea typeface="Arial" pitchFamily="34" charset="-122"/>
                 <a:cs typeface="Arial" pitchFamily="34" charset="-120"/>
               </a:rPr>
-              <a:t>CORE L3</a:t>
+              <a:t>本番確認</a:t>
             </a:r>
             <a:endParaRPr lang="en-US" sz="1500" dirty="0"/>
           </a:p>
@@ -6805,7 +6805,7 @@
                 <a:ea typeface="Arial" pitchFamily="34" charset="-122"/>
                 <a:cs typeface="Arial" pitchFamily="34" charset="-120"/>
               </a:rPr>
-              <a:t>inbox readback / real location</a:t>
+              <a:t>受信箱の読取り / 実際の位置情報</a:t>
             </a:r>
             <a:endParaRPr lang="en-US" sz="1350" dirty="0"/>
           </a:p>
@@ -6963,7 +6963,7 @@
                 <a:ea typeface="Arial" pitchFamily="34" charset="-122"/>
                 <a:cs typeface="Arial" pitchFamily="34" charset="-120"/>
               </a:rPr>
-              <a:t>AUTONOMY WITH GUARDRAILS</a:t>
+              <a:t>安全のためのルール</a:t>
             </a:r>
             <a:endParaRPr lang="en-US" sz="1200" dirty="0"/>
           </a:p>
@@ -7000,15 +7000,35 @@
               <a:buNone/>
             </a:pPr>
             <a:r>
+              <a:rPr lang="en-US" sz="3600" dirty="0">
+                <a:solidFill>
+                  <a:srgbClr val="F7F4EA"/>
+                </a:solidFill>
+                <a:latin typeface="Arial" pitchFamily="34" charset="0"/>
+                <a:ea typeface="Arial" pitchFamily="34" charset="-122"/>
+                <a:cs typeface="Arial" pitchFamily="34" charset="-120"/>
+              </a:rPr>
+              <a:t>自動化の</a:t>
+            </a:r>
+            <a:pPr algn="l" indent="0" marL="0">
+              <a:lnSpc>
+                <a:spcPts val="4104"/>
+              </a:lnSpc>
+              <a:spcBef>
+                <a:spcPts val="1050"/>
+              </a:spcBef>
+              <a:buNone/>
+            </a:pPr>
+            <a:r>
               <a:rPr lang="en-US" sz="3600" b="1" dirty="0">
                 <a:solidFill>
-                  <a:srgbClr val="F7F4EA"/>
-                </a:solidFill>
-                <a:latin typeface="Arial" pitchFamily="34" charset="0"/>
-                <a:ea typeface="Arial" pitchFamily="34" charset="-122"/>
-                <a:cs typeface="Arial" pitchFamily="34" charset="-120"/>
-              </a:rPr>
-              <a:t>自律 = 勝手に動くことではない</a:t>
+                  <a:srgbClr val="57D6C7"/>
+                </a:solidFill>
+                <a:latin typeface="Arial" pitchFamily="34" charset="0"/>
+                <a:ea typeface="Arial" pitchFamily="34" charset="-122"/>
+                <a:cs typeface="Arial" pitchFamily="34" charset="-120"/>
+              </a:rPr>
+              <a:t>境界</a:t>
             </a:r>
             <a:endParaRPr lang="en-US" sz="3600" dirty="0"/>
           </a:p>
@@ -7204,7 +7224,7 @@
                 <a:ea typeface="Arial" pitchFamily="34" charset="-122"/>
                 <a:cs typeface="Arial" pitchFamily="34" charset="-120"/>
               </a:rPr>
-              <a:t>REPORT, DON'T ASK</a:t>
+              <a:t>任せた範囲</a:t>
             </a:r>
             <a:endParaRPr lang="en-US" sz="1275" dirty="0"/>
           </a:p>
@@ -7249,7 +7269,7 @@
                 <a:ea typeface="Arial" pitchFamily="34" charset="-122"/>
                 <a:cs typeface="Arial" pitchFamily="34" charset="-120"/>
               </a:rPr>
-              <a:t>委任内は実行して報告</a:t>
+              <a:t>実行してから報告</a:t>
             </a:r>
             <a:endParaRPr lang="en-US" sz="2175" dirty="0"/>
           </a:p>
@@ -7294,7 +7314,7 @@
                 <a:ea typeface="Arial" pitchFamily="34" charset="-122"/>
                 <a:cs typeface="Arial" pitchFamily="34" charset="-120"/>
               </a:rPr>
-              <a:t>本人しか決められない時だけ、2〜3択のclosed Qを1回。</a:t>
+              <a:t>本人にしか決められない時だけ、短い選択肢を一度だけ聞く。</a:t>
             </a:r>
             <a:endParaRPr lang="en-US" sz="1800" dirty="0"/>
           </a:p>
@@ -7339,7 +7359,7 @@
                 <a:ea typeface="Arial" pitchFamily="34" charset="-122"/>
                 <a:cs typeface="Arial" pitchFamily="34" charset="-120"/>
               </a:rPr>
-              <a:t>同じ質問は二度しない。</a:t>
+              <a:t>同じことは聞かない。</a:t>
             </a:r>
             <a:endParaRPr lang="en-US" sz="1800" dirty="0"/>
           </a:p>
@@ -7505,7 +7525,7 @@
                 <a:ea typeface="Arial" pitchFamily="34" charset="-122"/>
                 <a:cs typeface="Arial" pitchFamily="34" charset="-120"/>
               </a:rPr>
-              <a:t>CONTEXT GATES</a:t>
+              <a:t>使える情報</a:t>
             </a:r>
             <a:endParaRPr lang="en-US" sz="1275" dirty="0"/>
           </a:p>
@@ -7550,7 +7570,7 @@
                 <a:ea typeface="Arial" pitchFamily="34" charset="-122"/>
                 <a:cs typeface="Arial" pitchFamily="34" charset="-120"/>
               </a:rPr>
-              <a:t>信頼を一段ずつ解錠</a:t>
+              <a:t>権限は必要な分だけ</a:t>
             </a:r>
             <a:endParaRPr lang="en-US" sz="2175" dirty="0"/>
           </a:p>
@@ -7565,7 +7585,7 @@
         <p:spPr>
           <a:xfrm>
             <a:off x="4591050" y="3230761"/>
-            <a:ext cx="3060383" cy="639961"/>
+            <a:ext cx="3060383" cy="959941"/>
           </a:xfrm>
           <a:prstGeom prst="rect">
             <a:avLst/>
@@ -7595,7 +7615,7 @@
                 <a:ea typeface="Arial" pitchFamily="34" charset="-122"/>
                 <a:cs typeface="Arial" pitchFamily="34" charset="-120"/>
               </a:rPr>
-              <a:t>calendar → Telegram → location → wallet。</a:t>
+              <a:t>カレンダー、Telegram、位置情報、ウォレットの順に接続。</a:t>
             </a:r>
             <a:endParaRPr lang="en-US" sz="1800" dirty="0"/>
           </a:p>
@@ -7609,7 +7629,7 @@
         </p:nvSpPr>
         <p:spPr>
           <a:xfrm>
-            <a:off x="4591050" y="4156472"/>
+            <a:off x="4591050" y="4476452"/>
             <a:ext cx="3060383" cy="319980"/>
           </a:xfrm>
           <a:prstGeom prst="rect">
@@ -7640,7 +7660,7 @@
                 <a:ea typeface="Arial" pitchFamily="34" charset="-122"/>
                 <a:cs typeface="Arial" pitchFamily="34" charset="-120"/>
               </a:rPr>
-              <a:t>最初に全部を要求しない。</a:t>
+              <a:t>最初から全部は求めない。</a:t>
             </a:r>
             <a:endParaRPr lang="en-US" sz="1800" dirty="0"/>
           </a:p>
@@ -7806,7 +7826,7 @@
                 <a:ea typeface="Arial" pitchFamily="34" charset="-122"/>
                 <a:cs typeface="Arial" pitchFamily="34" charset="-120"/>
               </a:rPr>
-              <a:t>EVIDENCE, NOT CLAIMS</a:t>
+              <a:t>実行結果</a:t>
             </a:r>
             <a:endParaRPr lang="en-US" sz="1275" dirty="0"/>
           </a:p>
@@ -7851,7 +7871,7 @@
                 <a:ea typeface="Arial" pitchFamily="34" charset="-122"/>
                 <a:cs typeface="Arial" pitchFamily="34" charset="-120"/>
               </a:rPr>
-              <a:t>失敗を正直に出す</a:t>
+              <a:t>失敗もそのまま伝える</a:t>
             </a:r>
             <a:endParaRPr lang="en-US" sz="2175" dirty="0"/>
           </a:p>
@@ -7866,7 +7886,7 @@
         <p:spPr>
           <a:xfrm>
             <a:off x="8258175" y="3230761"/>
-            <a:ext cx="3060383" cy="959941"/>
+            <a:ext cx="3060383" cy="639961"/>
           </a:xfrm>
           <a:prstGeom prst="rect">
             <a:avLst/>
@@ -7896,7 +7916,7 @@
                 <a:ea typeface="Arial" pitchFamily="34" charset="-122"/>
                 <a:cs typeface="Arial" pitchFamily="34" charset="-120"/>
               </a:rPr>
-              <a:t>API 200や自己申告ではなく、録音・Message-ID・tx hash・投稿URLで証明。</a:t>
+              <a:t>録音、Message-ID、取引ID、投稿URLを確認する。</a:t>
             </a:r>
             <a:endParaRPr lang="en-US" sz="1800" dirty="0"/>
           </a:p>
@@ -7910,7 +7930,7 @@
         </p:nvSpPr>
         <p:spPr>
           <a:xfrm>
-            <a:off x="8258175" y="4476452"/>
+            <a:off x="8258175" y="4156472"/>
             <a:ext cx="3060383" cy="319980"/>
           </a:xfrm>
           <a:prstGeom prst="rect">
@@ -7941,7 +7961,7 @@
                 <a:ea typeface="Arial" pitchFamily="34" charset="-122"/>
                 <a:cs typeface="Arial" pitchFamily="34" charset="-120"/>
               </a:rPr>
-              <a:t>黙って放置しない。</a:t>
+              <a:t>エラーを隠さない。</a:t>
             </a:r>
             <a:endParaRPr lang="en-US" sz="1800" dirty="0"/>
           </a:p>
@@ -8099,7 +8119,7 @@
                 <a:ea typeface="Arial" pitchFamily="34" charset="-122"/>
                 <a:cs typeface="Arial" pitchFamily="34" charset="-120"/>
               </a:rPr>
-              <a:t>THE DESTINATION</a:t>
+              <a:t>長期目標</a:t>
             </a:r>
             <a:endParaRPr lang="en-US" sz="1200" dirty="0"/>
           </a:p>
@@ -8144,7 +8164,7 @@
                 <a:ea typeface="Arial" pitchFamily="34" charset="-122"/>
                 <a:cs typeface="Arial" pitchFamily="34" charset="-120"/>
               </a:rPr>
-              <a:t>AIが自分の</a:t>
+              <a:t>AI自身が、</a:t>
             </a:r>
             <a:pPr algn="l" indent="0" marL="0">
               <a:lnSpc>
@@ -8164,27 +8184,7 @@
                 <a:ea typeface="Arial" pitchFamily="34" charset="-122"/>
                 <a:cs typeface="Arial" pitchFamily="34" charset="-120"/>
               </a:rPr>
-              <a:t>食費と家賃</a:t>
-            </a:r>
-            <a:pPr algn="l" indent="0" marL="0">
-              <a:lnSpc>
-                <a:spcPts val="4104"/>
-              </a:lnSpc>
-              <a:spcBef>
-                <a:spcPts val="1050"/>
-              </a:spcBef>
-              <a:buNone/>
-            </a:pPr>
-            <a:r>
-              <a:rPr lang="en-US" sz="3600" dirty="0">
-                <a:solidFill>
-                  <a:srgbClr val="F7F4EA"/>
-                </a:solidFill>
-                <a:latin typeface="Arial" pitchFamily="34" charset="0"/>
-                <a:ea typeface="Arial" pitchFamily="34" charset="-122"/>
-                <a:cs typeface="Arial" pitchFamily="34" charset="-120"/>
-              </a:rPr>
-              <a:t>を払う</a:t>
+              <a:t>運営費を稼ぐ</a:t>
             </a:r>
             <a:endParaRPr lang="en-US" sz="3600" dirty="0"/>
           </a:p>
@@ -8292,7 +8292,7 @@
                 <a:ea typeface="Arial" pitchFamily="34" charset="-122"/>
                 <a:cs typeface="Arial" pitchFamily="34" charset="-120"/>
               </a:rPr>
-              <a:t>EXTERNAL</a:t>
+              <a:t>仕事</a:t>
             </a:r>
             <a:endParaRPr lang="en-US" sz="1275" dirty="0"/>
           </a:p>
@@ -8337,7 +8337,7 @@
                 <a:ea typeface="Arial" pitchFamily="34" charset="-122"/>
                 <a:cs typeface="Arial" pitchFamily="34" charset="-120"/>
               </a:rPr>
-              <a:t>外部経済</a:t>
+              <a:t>仕事をする</a:t>
             </a:r>
             <a:endParaRPr lang="en-US" sz="1875" dirty="0"/>
           </a:p>
@@ -8382,7 +8382,7 @@
                 <a:ea typeface="Arial" pitchFamily="34" charset="-122"/>
                 <a:cs typeface="Arial" pitchFamily="34" charset="-120"/>
               </a:rPr>
-              <a:t>仕事・販売</a:t>
+              <a:t>販売・受託</a:t>
             </a:r>
             <a:endParaRPr lang="en-US" sz="1275" dirty="0"/>
           </a:p>
@@ -8502,7 +8502,7 @@
                 <a:ea typeface="Arial" pitchFamily="34" charset="-122"/>
                 <a:cs typeface="Arial" pitchFamily="34" charset="-120"/>
               </a:rPr>
-              <a:t>EARN</a:t>
+              <a:t>収入</a:t>
             </a:r>
             <a:endParaRPr lang="en-US" sz="1275" dirty="0"/>
           </a:p>
@@ -8517,7 +8517,7 @@
         <p:spPr>
           <a:xfrm>
             <a:off x="3292793" y="3171230"/>
-            <a:ext cx="1263015" cy="297656"/>
+            <a:ext cx="1263015" cy="595313"/>
           </a:xfrm>
           <a:prstGeom prst="rect">
             <a:avLst/>
@@ -8547,7 +8547,7 @@
                 <a:ea typeface="Arial" pitchFamily="34" charset="-122"/>
                 <a:cs typeface="Arial" pitchFamily="34" charset="-120"/>
               </a:rPr>
-              <a:t>AIが稼ぐ</a:t>
+              <a:t>収入を受け取る</a:t>
             </a:r>
             <a:endParaRPr lang="en-US" sz="1875" dirty="0"/>
           </a:p>
@@ -8561,7 +8561,7 @@
         </p:nvSpPr>
         <p:spPr>
           <a:xfrm>
-            <a:off x="3292793" y="3611761"/>
+            <a:off x="3292793" y="3909417"/>
             <a:ext cx="1263015" cy="218480"/>
           </a:xfrm>
           <a:prstGeom prst="rect">
@@ -8592,7 +8592,7 @@
                 <a:ea typeface="Arial" pitchFamily="34" charset="-122"/>
                 <a:cs typeface="Arial" pitchFamily="34" charset="-120"/>
               </a:rPr>
-              <a:t>wallet + ledger</a:t>
+              <a:t>ウォレット</a:t>
             </a:r>
             <a:endParaRPr lang="en-US" sz="1275" dirty="0"/>
           </a:p>
@@ -8712,7 +8712,7 @@
                 <a:ea typeface="Arial" pitchFamily="34" charset="-122"/>
                 <a:cs typeface="Arial" pitchFamily="34" charset="-120"/>
               </a:rPr>
-              <a:t>PAY</a:t>
+              <a:t>支払い</a:t>
             </a:r>
             <a:endParaRPr lang="en-US" sz="1275" dirty="0"/>
           </a:p>
@@ -8727,7 +8727,7 @@
         <p:spPr>
           <a:xfrm>
             <a:off x="5521643" y="3171230"/>
-            <a:ext cx="1263015" cy="297656"/>
+            <a:ext cx="1263015" cy="595313"/>
           </a:xfrm>
           <a:prstGeom prst="rect">
             <a:avLst/>
@@ -8757,7 +8757,7 @@
                 <a:ea typeface="Arial" pitchFamily="34" charset="-122"/>
                 <a:cs typeface="Arial" pitchFamily="34" charset="-120"/>
               </a:rPr>
-              <a:t>自分を維持</a:t>
+              <a:t>運営費を払う</a:t>
             </a:r>
             <a:endParaRPr lang="en-US" sz="1875" dirty="0"/>
           </a:p>
@@ -8771,8 +8771,8 @@
         </p:nvSpPr>
         <p:spPr>
           <a:xfrm>
-            <a:off x="5521643" y="3611761"/>
-            <a:ext cx="1263015" cy="218480"/>
+            <a:off x="5521643" y="3909417"/>
+            <a:ext cx="1263015" cy="436959"/>
           </a:xfrm>
           <a:prstGeom prst="rect">
             <a:avLst/>
@@ -8802,7 +8802,7 @@
                 <a:ea typeface="Arial" pitchFamily="34" charset="-122"/>
                 <a:cs typeface="Arial" pitchFamily="34" charset="-120"/>
               </a:rPr>
-              <a:t>model + cloud</a:t>
+              <a:t>モデル・サーバー</a:t>
             </a:r>
             <a:endParaRPr lang="en-US" sz="1275" dirty="0"/>
           </a:p>
@@ -8922,7 +8922,7 @@
                 <a:ea typeface="Arial" pitchFamily="34" charset="-122"/>
                 <a:cs typeface="Arial" pitchFamily="34" charset="-120"/>
               </a:rPr>
-              <a:t>SERVE</a:t>
+              <a:t>送金</a:t>
             </a:r>
             <a:endParaRPr lang="en-US" sz="1275" dirty="0"/>
           </a:p>
@@ -8967,7 +8967,7 @@
                 <a:ea typeface="Arial" pitchFamily="34" charset="-122"/>
                 <a:cs typeface="Arial" pitchFamily="34" charset="-120"/>
               </a:rPr>
-              <a:t>人を支える</a:t>
+              <a:t>残りを送る</a:t>
             </a:r>
             <a:endParaRPr lang="en-US" sz="1875" dirty="0"/>
           </a:p>
@@ -8982,7 +8982,7 @@
         <p:spPr>
           <a:xfrm>
             <a:off x="7750493" y="3611761"/>
-            <a:ext cx="1263015" cy="436959"/>
+            <a:ext cx="1263015" cy="218480"/>
           </a:xfrm>
           <a:prstGeom prst="rect">
             <a:avLst/>
@@ -9012,7 +9012,7 @@
                 <a:ea typeface="Arial" pitchFamily="34" charset="-122"/>
                 <a:cs typeface="Arial" pitchFamily="34" charset="-120"/>
               </a:rPr>
-              <a:t>body / mind / finance</a:t>
+              <a:t>本人の口座へ</a:t>
             </a:r>
             <a:endParaRPr lang="en-US" sz="1275" dirty="0"/>
           </a:p>
@@ -9132,7 +9132,7 @@
                 <a:ea typeface="Arial" pitchFamily="34" charset="-122"/>
                 <a:cs typeface="Arial" pitchFamily="34" charset="-120"/>
               </a:rPr>
-              <a:t>FREE</a:t>
+              <a:t>還元</a:t>
             </a:r>
             <a:endParaRPr lang="en-US" sz="1275" dirty="0"/>
           </a:p>
@@ -9177,7 +9177,7 @@
                 <a:ea typeface="Arial" pitchFamily="34" charset="-122"/>
                 <a:cs typeface="Arial" pitchFamily="34" charset="-120"/>
               </a:rPr>
-              <a:t>負担を縮める</a:t>
+              <a:t>利用料を下げる</a:t>
             </a:r>
             <a:endParaRPr lang="en-US" sz="1875" dirty="0"/>
           </a:p>
@@ -9192,7 +9192,7 @@
         <p:spPr>
           <a:xfrm>
             <a:off x="9979343" y="3909417"/>
-            <a:ext cx="1263015" cy="436959"/>
+            <a:ext cx="1263015" cy="218480"/>
           </a:xfrm>
           <a:prstGeom prst="rect">
             <a:avLst/>
@@ -9222,7 +9222,7 @@
                 <a:ea typeface="Arial" pitchFamily="34" charset="-122"/>
                 <a:cs typeface="Arial" pitchFamily="34" charset="-120"/>
               </a:rPr>
-              <a:t>subscription → ¥0</a:t>
+              <a:t>月額 → 0円</a:t>
             </a:r>
             <a:endParaRPr lang="en-US" sz="1275" dirty="0"/>
           </a:p>
@@ -9309,7 +9309,7 @@
                 <a:ea typeface="Arial" pitchFamily="34" charset="-122"/>
                 <a:cs typeface="Arial" pitchFamily="34" charset="-120"/>
               </a:rPr>
-              <a:t>精神的に、身体的に、経済的に健康な人生をオートパイロットへ</a:t>
+              <a:t>毎日の予定、健康、お金の用事を、スマホ1台から任せられる状態へ</a:t>
             </a:r>
             <a:endParaRPr lang="en-US" sz="1800" dirty="0"/>
           </a:p>
@@ -9323,8 +9323,8 @@
         </p:nvSpPr>
         <p:spPr>
           <a:xfrm>
-            <a:off x="10787360" y="5676900"/>
-            <a:ext cx="718840" cy="304800"/>
+            <a:off x="10972800" y="5676900"/>
+            <a:ext cx="533400" cy="304800"/>
           </a:xfrm>
           <a:prstGeom prst="roundRect">
             <a:avLst>
@@ -9357,8 +9357,8 @@
         </p:nvSpPr>
         <p:spPr>
           <a:xfrm>
-            <a:off x="10920710" y="5762625"/>
-            <a:ext cx="461183" cy="133350"/>
+            <a:off x="11106150" y="5762625"/>
+            <a:ext cx="272034" cy="133350"/>
           </a:xfrm>
           <a:prstGeom prst="rect">
             <a:avLst/>
@@ -9385,7 +9385,7 @@
                 <a:ea typeface="Arial" pitchFamily="34" charset="-122"/>
                 <a:cs typeface="Arial" pitchFamily="34" charset="-120"/>
               </a:rPr>
-              <a:t>VISION</a:t>
+              <a:t>今後</a:t>
             </a:r>
             <a:endParaRPr lang="en-US" sz="1050" dirty="0"/>
           </a:p>
@@ -9543,7 +9543,7 @@
                 <a:ea typeface="Arial" pitchFamily="34" charset="-122"/>
                 <a:cs typeface="Arial" pitchFamily="34" charset="-120"/>
               </a:rPr>
-              <a:t>ONE SENTENCE</a:t>
+              <a:t>LIFE MANAGER</a:t>
             </a:r>
             <a:endParaRPr lang="en-US" sz="1200" dirty="0"/>
           </a:p>
@@ -9588,7 +9588,7 @@
                 <a:ea typeface="Arial" pitchFamily="34" charset="-122"/>
                 <a:cs typeface="Arial" pitchFamily="34" charset="-120"/>
               </a:rPr>
-              <a:t>Life Managerは
+              <a:t>暮らしの用事を、
 </a:t>
             </a:r>
             <a:pPr algn="l" indent="0" marL="0">
@@ -9609,7 +9609,7 @@
                 <a:ea typeface="Arial" pitchFamily="34" charset="-122"/>
                 <a:cs typeface="Arial" pitchFamily="34" charset="-120"/>
               </a:rPr>
-              <a:t>アプリではない。</a:t>
+              <a:t>先回りして片づける。</a:t>
             </a:r>
             <a:endParaRPr lang="en-US" sz="5400" dirty="0"/>
           </a:p>
@@ -9624,21 +9624,21 @@
         <p:spPr>
           <a:xfrm>
             <a:off x="838200" y="3367088"/>
-            <a:ext cx="10725912" cy="998934"/>
-          </a:xfrm>
-          <a:prstGeom prst="rect">
-            <a:avLst/>
-          </a:prstGeom>
-          <a:noFill/>
-          <a:ln/>
-        </p:spPr>
-        <p:txBody>
-          <a:bodyPr wrap="square" lIns="0" tIns="0" rIns="0" bIns="0" rtlCol="0" anchor="t"/>
-          <a:lstStyle/>
-          <a:p>
-            <a:pPr algn="l" indent="0" marL="0">
-              <a:lnSpc>
-                <a:spcPts val="3933"/>
+            <a:ext cx="10725912" cy="912019"/>
+          </a:xfrm>
+          <a:prstGeom prst="rect">
+            <a:avLst/>
+          </a:prstGeom>
+          <a:noFill/>
+          <a:ln/>
+        </p:spPr>
+        <p:txBody>
+          <a:bodyPr wrap="square" lIns="0" tIns="0" rIns="0" bIns="0" rtlCol="0" anchor="t"/>
+          <a:lstStyle/>
+          <a:p>
+            <a:pPr algn="l" indent="0" marL="0">
+              <a:lnSpc>
+                <a:spcPts val="3591"/>
               </a:lnSpc>
               <a:spcBef>
                 <a:spcPts val="2550"/>
@@ -9646,7 +9646,7 @@
               <a:buNone/>
             </a:pPr>
             <a:r>
-              <a:rPr lang="en-US" sz="3450" dirty="0">
+              <a:rPr lang="en-US" sz="3150" dirty="0">
                 <a:solidFill>
                   <a:srgbClr val="A6B3BE"/>
                 </a:solidFill>
@@ -9654,14 +9654,14 @@
                 <a:ea typeface="Arial" pitchFamily="34" charset="-122"/>
                 <a:cs typeface="Arial" pitchFamily="34" charset="-120"/>
               </a:rPr>
-              <a:t>人生を観測し、動かし、証明し、学ぶ</a:t>
-            </a:r>
-            <a:endParaRPr lang="en-US" sz="3450" dirty="0"/>
-          </a:p>
-          <a:p>
-            <a:pPr algn="l" indent="0" marL="0">
-              <a:lnSpc>
-                <a:spcPts val="3933"/>
+              <a:t>予定と場所を読み、必要な処理を実行する。</a:t>
+            </a:r>
+            <a:endParaRPr lang="en-US" sz="3150" dirty="0"/>
+          </a:p>
+          <a:p>
+            <a:pPr algn="l" indent="0" marL="0">
+              <a:lnSpc>
+                <a:spcPts val="3591"/>
               </a:lnSpc>
               <a:spcBef>
                 <a:spcPts val="2550"/>
@@ -9669,7 +9669,7 @@
               <a:buNone/>
             </a:pPr>
             <a:r>
-              <a:rPr lang="en-US" sz="3450" dirty="0">
+              <a:rPr lang="en-US" sz="3150" dirty="0">
                 <a:solidFill>
                   <a:srgbClr val="A6B3BE"/>
                 </a:solidFill>
@@ -9677,9 +9677,9 @@
                 <a:ea typeface="Arial" pitchFamily="34" charset="-122"/>
                 <a:cs typeface="Arial" pitchFamily="34" charset="-120"/>
               </a:rPr>
-              <a:t>自律オペレーターである。</a:t>
-            </a:r>
-            <a:endParaRPr lang="en-US" sz="3450" dirty="0"/>
+              <a:t>結果を本人へ伝え、失敗したら直す。</a:t>
+            </a:r>
+            <a:endParaRPr lang="en-US" sz="3150" dirty="0"/>
           </a:p>
         </p:txBody>
       </p:sp>
@@ -9692,7 +9692,7 @@
         <p:spPr>
           <a:xfrm>
             <a:off x="838200" y="5353050"/>
-            <a:ext cx="1695599" cy="304800"/>
+            <a:ext cx="1885652" cy="304800"/>
           </a:xfrm>
           <a:prstGeom prst="roundRect">
             <a:avLst>
@@ -9726,7 +9726,7 @@
         <p:spPr>
           <a:xfrm>
             <a:off x="971550" y="5438775"/>
-            <a:ext cx="1457477" cy="133350"/>
+            <a:ext cx="1651331" cy="133350"/>
           </a:xfrm>
           <a:prstGeom prst="rect">
             <a:avLst/>
@@ -9753,7 +9753,7 @@
                 <a:ea typeface="Arial" pitchFamily="34" charset="-122"/>
                 <a:cs typeface="Arial" pitchFamily="34" charset="-120"/>
               </a:rPr>
-              <a:t>BUILT: DAILY + PANEL</a:t>
+              <a:t>稼働中：予定 + 個人パネル</a:t>
             </a:r>
             <a:endParaRPr lang="en-US" sz="1050" dirty="0"/>
           </a:p>
@@ -9767,8 +9767,8 @@
         </p:nvSpPr>
         <p:spPr>
           <a:xfrm>
-            <a:off x="2667149" y="5353050"/>
-            <a:ext cx="1685776" cy="304800"/>
+            <a:off x="2857202" y="5353050"/>
+            <a:ext cx="1485602" cy="304800"/>
           </a:xfrm>
           <a:prstGeom prst="roundRect">
             <a:avLst>
@@ -9801,8 +9801,8 @@
         </p:nvSpPr>
         <p:spPr>
           <a:xfrm>
-            <a:off x="2800499" y="5438775"/>
-            <a:ext cx="1447458" cy="133350"/>
+            <a:off x="2990552" y="5438775"/>
+            <a:ext cx="1243280" cy="133350"/>
           </a:xfrm>
           <a:prstGeom prst="rect">
             <a:avLst/>
@@ -9829,7 +9829,7 @@
                 <a:ea typeface="Arial" pitchFamily="34" charset="-122"/>
                 <a:cs typeface="Arial" pitchFamily="34" charset="-120"/>
               </a:rPr>
-              <a:t>NEXT: REPO + LOOPS</a:t>
+              <a:t>次：統合 + 自動修復</a:t>
             </a:r>
             <a:endParaRPr lang="en-US" sz="1050" dirty="0"/>
           </a:p>
@@ -9843,8 +9843,8 @@
         </p:nvSpPr>
         <p:spPr>
           <a:xfrm>
-            <a:off x="4486275" y="5353050"/>
-            <a:ext cx="2296716" cy="304800"/>
+            <a:off x="4476155" y="5353050"/>
+            <a:ext cx="1866900" cy="304800"/>
           </a:xfrm>
           <a:prstGeom prst="roundRect">
             <a:avLst>
@@ -9877,8 +9877,8 @@
         </p:nvSpPr>
         <p:spPr>
           <a:xfrm>
-            <a:off x="4619625" y="5438775"/>
-            <a:ext cx="2070616" cy="133350"/>
+            <a:off x="4609505" y="5438775"/>
+            <a:ext cx="1632204" cy="133350"/>
           </a:xfrm>
           <a:prstGeom prst="rect">
             <a:avLst/>
@@ -9905,7 +9905,7 @@
                 <a:ea typeface="Arial" pitchFamily="34" charset="-122"/>
                 <a:cs typeface="Arial" pitchFamily="34" charset="-120"/>
               </a:rPr>
-              <a:t>VISION: SELF-FUNDED LIFE OS</a:t>
+              <a:t>目標：自分で運営費を稼ぐ</a:t>
             </a:r>
             <a:endParaRPr lang="en-US" sz="1050" dirty="0"/>
           </a:p>
@@ -10063,7 +10063,7 @@
                 <a:ea typeface="Arial" pitchFamily="34" charset="-122"/>
                 <a:cs typeface="Arial" pitchFamily="34" charset="-120"/>
               </a:rPr>
-              <a:t>WHY</a:t>
+              <a:t>いま困っていること</a:t>
             </a:r>
             <a:endParaRPr lang="en-US" sz="1200" dirty="0"/>
           </a:p>
@@ -10108,7 +10108,7 @@
                 <a:ea typeface="Arial" pitchFamily="34" charset="-122"/>
                 <a:cs typeface="Arial" pitchFamily="34" charset="-120"/>
               </a:rPr>
-              <a:t>問題は、生活が</a:t>
+              <a:t>暮らしには、</a:t>
             </a:r>
             <a:pPr algn="l" indent="0" marL="0">
               <a:lnSpc>
@@ -10128,27 +10128,7 @@
                 <a:ea typeface="Arial" pitchFamily="34" charset="-122"/>
                 <a:cs typeface="Arial" pitchFamily="34" charset="-120"/>
               </a:rPr>
-              <a:t>人間の頭のRAM</a:t>
-            </a:r>
-            <a:pPr algn="l" indent="0" marL="0">
-              <a:lnSpc>
-                <a:spcPts val="4104"/>
-              </a:lnSpc>
-              <a:spcBef>
-                <a:spcPts val="1050"/>
-              </a:spcBef>
-              <a:buNone/>
-            </a:pPr>
-            <a:r>
-              <a:rPr lang="en-US" sz="3600" dirty="0">
-                <a:solidFill>
-                  <a:srgbClr val="F7F4EA"/>
-                </a:solidFill>
-                <a:latin typeface="Arial" pitchFamily="34" charset="0"/>
-                <a:ea typeface="Arial" pitchFamily="34" charset="-122"/>
-                <a:cs typeface="Arial" pitchFamily="34" charset="-120"/>
-              </a:rPr>
-              <a:t>を食べ続けること</a:t>
+              <a:t>覚えておく用事が多い</a:t>
             </a:r>
             <a:endParaRPr lang="en-US" sz="3600" dirty="0"/>
           </a:p>
@@ -10256,7 +10236,7 @@
                 <a:ea typeface="Arial" pitchFamily="34" charset="-122"/>
                 <a:cs typeface="Arial" pitchFamily="34" charset="-120"/>
               </a:rPr>
-              <a:t>SCHEDULE</a:t>
+              <a:t>予定</a:t>
             </a:r>
             <a:endParaRPr lang="en-US" sz="1275" dirty="0"/>
           </a:p>
@@ -10346,7 +10326,7 @@
                 <a:ea typeface="Arial" pitchFamily="34" charset="-122"/>
                 <a:cs typeface="Arial" pitchFamily="34" charset="-120"/>
               </a:rPr>
-              <a:t>時計を見続ける</a:t>
+              <a:t>何度も時計を見る</a:t>
             </a:r>
             <a:endParaRPr lang="en-US" sz="1800" dirty="0"/>
           </a:p>
@@ -10424,7 +10404,7 @@
                 <a:ea typeface="Arial" pitchFamily="34" charset="-122"/>
                 <a:cs typeface="Arial" pitchFamily="34" charset="-120"/>
               </a:rPr>
-              <a:t>TRAVEL</a:t>
+              <a:t>移動</a:t>
             </a:r>
             <a:endParaRPr lang="en-US" sz="1275" dirty="0"/>
           </a:p>
@@ -10469,7 +10449,7 @@
                 <a:ea typeface="Arial" pitchFamily="34" charset="-122"/>
                 <a:cs typeface="Arial" pitchFamily="34" charset="-120"/>
               </a:rPr>
-              <a:t>何分前に出る？</a:t>
+              <a:t>何時に出る？</a:t>
             </a:r>
             <a:endParaRPr lang="en-US" sz="1875" dirty="0"/>
           </a:p>
@@ -10514,7 +10494,7 @@
                 <a:ea typeface="Arial" pitchFamily="34" charset="-122"/>
                 <a:cs typeface="Arial" pitchFamily="34" charset="-120"/>
               </a:rPr>
-              <a:t>毎回逆算する</a:t>
+              <a:t>毎回、自分で逆算</a:t>
             </a:r>
             <a:endParaRPr lang="en-US" sz="1800" dirty="0"/>
           </a:p>
@@ -10592,7 +10572,7 @@
                 <a:ea typeface="Arial" pitchFamily="34" charset="-122"/>
                 <a:cs typeface="Arial" pitchFamily="34" charset="-120"/>
               </a:rPr>
-              <a:t>CARE</a:t>
+              <a:t>健康</a:t>
             </a:r>
             <a:endParaRPr lang="en-US" sz="1275" dirty="0"/>
           </a:p>
@@ -10682,7 +10662,7 @@
                 <a:ea typeface="Arial" pitchFamily="34" charset="-122"/>
                 <a:cs typeface="Arial" pitchFamily="34" charset="-120"/>
               </a:rPr>
-              <a:t>先送りが住みつく</a:t>
+              <a:t>気づくと来週</a:t>
             </a:r>
             <a:endParaRPr lang="en-US" sz="1800" dirty="0"/>
           </a:p>
@@ -10760,7 +10740,7 @@
                 <a:ea typeface="Arial" pitchFamily="34" charset="-122"/>
                 <a:cs typeface="Arial" pitchFamily="34" charset="-120"/>
               </a:rPr>
-              <a:t>MONEY</a:t>
+              <a:t>お金</a:t>
             </a:r>
             <a:endParaRPr lang="en-US" sz="1275" dirty="0"/>
           </a:p>
@@ -10820,21 +10800,21 @@
         <p:spPr>
           <a:xfrm>
             <a:off x="9229725" y="5107186"/>
-            <a:ext cx="2040255" cy="639961"/>
-          </a:xfrm>
-          <a:prstGeom prst="rect">
-            <a:avLst/>
-          </a:prstGeom>
-          <a:noFill/>
-          <a:ln/>
-        </p:spPr>
-        <p:txBody>
-          <a:bodyPr wrap="square" lIns="0" tIns="0" rIns="0" bIns="0" rtlCol="0" anchor="t"/>
-          <a:lstStyle/>
-          <a:p>
-            <a:pPr algn="l" indent="0" marL="0">
-              <a:lnSpc>
-                <a:spcPts val="2520"/>
+            <a:ext cx="2040255" cy="247650"/>
+          </a:xfrm>
+          <a:prstGeom prst="rect">
+            <a:avLst/>
+          </a:prstGeom>
+          <a:noFill/>
+          <a:ln/>
+        </p:spPr>
+        <p:txBody>
+          <a:bodyPr wrap="square" lIns="0" tIns="0" rIns="0" bIns="0" rtlCol="0" anchor="t"/>
+          <a:lstStyle/>
+          <a:p>
+            <a:pPr algn="l" indent="0" marL="0">
+              <a:lnSpc>
+                <a:spcPts val="1950"/>
               </a:lnSpc>
               <a:spcBef>
                 <a:spcPts val="750"/>
@@ -10842,7 +10822,7 @@
               <a:buNone/>
             </a:pPr>
             <a:r>
-              <a:rPr lang="en-US" sz="1800" dirty="0">
+              <a:rPr lang="en-US" sz="1500" dirty="0">
                 <a:solidFill>
                   <a:srgbClr val="A6B3BE"/>
                 </a:solidFill>
@@ -10850,9 +10830,9 @@
                 <a:ea typeface="Arial" pitchFamily="34" charset="-122"/>
                 <a:cs typeface="Arial" pitchFamily="34" charset="-120"/>
               </a:rPr>
-              <a:t>労働時間に縛られる</a:t>
-            </a:r>
-            <a:endParaRPr lang="en-US" sz="1800" dirty="0"/>
+              <a:t>考えるだけで終わる</a:t>
+            </a:r>
+            <a:endParaRPr lang="en-US" sz="1500" dirty="0"/>
           </a:p>
         </p:txBody>
       </p:sp>
@@ -10900,8 +10880,8 @@
         </p:nvSpPr>
         <p:spPr>
           <a:xfrm>
-            <a:off x="5476940" y="3084761"/>
-            <a:ext cx="1238119" cy="152400"/>
+            <a:off x="5449919" y="3199507"/>
+            <a:ext cx="1292162" cy="152400"/>
           </a:xfrm>
           <a:prstGeom prst="rect">
             <a:avLst/>
@@ -10928,7 +10908,7 @@
                 <a:ea typeface="Arial" pitchFamily="34" charset="-122"/>
                 <a:cs typeface="Arial" pitchFamily="34" charset="-120"/>
               </a:rPr>
-              <a:t>HUMAN RAM</a:t>
+              <a:t>頭から離れない</a:t>
             </a:r>
             <a:endParaRPr lang="en-US" sz="1200" dirty="0"/>
           </a:p>
@@ -10942,8 +10922,8 @@
         </p:nvSpPr>
         <p:spPr>
           <a:xfrm>
-            <a:off x="5042779" y="3408611"/>
-            <a:ext cx="2106442" cy="597098"/>
+            <a:off x="4705165" y="3523357"/>
+            <a:ext cx="2781669" cy="456009"/>
           </a:xfrm>
           <a:prstGeom prst="rect">
             <a:avLst/>
@@ -10957,7 +10937,7 @@
           <a:p>
             <a:pPr algn="ctr" indent="0" marL="0">
               <a:lnSpc>
-                <a:spcPts val="4703"/>
+                <a:spcPts val="3591"/>
               </a:lnSpc>
               <a:spcBef>
                 <a:spcPts val="1350"/>
@@ -10965,7 +10945,7 @@
               <a:buNone/>
             </a:pPr>
             <a:r>
-              <a:rPr lang="en-US" sz="4125" b="1" dirty="0">
+              <a:rPr lang="en-US" sz="3150" b="1" dirty="0">
                 <a:solidFill>
                   <a:srgbClr val="F7F4EA"/>
                 </a:solidFill>
@@ -10973,9 +10953,9 @@
                 <a:ea typeface="Arial" pitchFamily="34" charset="-122"/>
                 <a:cs typeface="Arial" pitchFamily="34" charset="-120"/>
               </a:rPr>
-              <a:t>常時満杯</a:t>
-            </a:r>
-            <a:endParaRPr lang="en-US" sz="4125" dirty="0"/>
+              <a:t>ずっと気になる</a:t>
+            </a:r>
+            <a:endParaRPr lang="en-US" sz="3150" dirty="0"/>
           </a:p>
         </p:txBody>
       </p:sp>
@@ -10987,8 +10967,8 @@
         </p:nvSpPr>
         <p:spPr>
           <a:xfrm>
-            <a:off x="4696968" y="4120009"/>
-            <a:ext cx="2798064" cy="319980"/>
+            <a:off x="5134166" y="4093666"/>
+            <a:ext cx="1923669" cy="231428"/>
           </a:xfrm>
           <a:prstGeom prst="rect">
             <a:avLst/>
@@ -11002,7 +10982,7 @@
           <a:p>
             <a:pPr algn="ctr" indent="0" marL="0">
               <a:lnSpc>
-                <a:spcPts val="2520"/>
+                <a:spcPts val="1823"/>
               </a:lnSpc>
               <a:spcBef>
                 <a:spcPts val="900"/>
@@ -11010,7 +10990,7 @@
               <a:buNone/>
             </a:pPr>
             <a:r>
-              <a:rPr lang="en-US" sz="1800" dirty="0">
+              <a:rPr lang="en-US" sz="1350" dirty="0">
                 <a:solidFill>
                   <a:srgbClr val="A6B3BE"/>
                 </a:solidFill>
@@ -11018,9 +10998,9 @@
                 <a:ea typeface="Arial" pitchFamily="34" charset="-122"/>
                 <a:cs typeface="Arial" pitchFamily="34" charset="-120"/>
               </a:rPr>
-              <a:t>忘れないために生きている</a:t>
-            </a:r>
-            <a:endParaRPr lang="en-US" sz="1800" dirty="0"/>
+              <a:t>一日中、気が休まらない</a:t>
+            </a:r>
+            <a:endParaRPr lang="en-US" sz="1350" dirty="0"/>
           </a:p>
         </p:txBody>
       </p:sp>
@@ -11176,7 +11156,7 @@
                 <a:ea typeface="Arial" pitchFamily="34" charset="-122"/>
                 <a:cs typeface="Arial" pitchFamily="34" charset="-120"/>
               </a:rPr>
-              <a:t>NORTH STAR</a:t>
+              <a:t>任せたいこと</a:t>
             </a:r>
             <a:endParaRPr lang="en-US" sz="1200" dirty="0"/>
           </a:p>
@@ -11221,7 +11201,7 @@
                 <a:ea typeface="Arial" pitchFamily="34" charset="-122"/>
                 <a:cs typeface="Arial" pitchFamily="34" charset="-120"/>
               </a:rPr>
-              <a:t>Life Manager = </a:t>
+              <a:t>Life Managerが扱う</a:t>
             </a:r>
             <a:pPr algn="l" indent="0" marL="0">
               <a:lnSpc>
@@ -11241,27 +11221,7 @@
                 <a:ea typeface="Arial" pitchFamily="34" charset="-122"/>
                 <a:cs typeface="Arial" pitchFamily="34" charset="-120"/>
               </a:rPr>
-              <a:t>頭脳</a:t>
-            </a:r>
-            <a:pPr algn="l" indent="0" marL="0">
-              <a:lnSpc>
-                <a:spcPts val="4104"/>
-              </a:lnSpc>
-              <a:spcBef>
-                <a:spcPts val="1050"/>
-              </a:spcBef>
-              <a:buNone/>
-            </a:pPr>
-            <a:r>
-              <a:rPr lang="en-US" sz="3600" dirty="0">
-                <a:solidFill>
-                  <a:srgbClr val="F7F4EA"/>
-                </a:solidFill>
-                <a:latin typeface="Arial" pitchFamily="34" charset="0"/>
-                <a:ea typeface="Arial" pitchFamily="34" charset="-122"/>
-                <a:cs typeface="Arial" pitchFamily="34" charset="-120"/>
-              </a:rPr>
-              <a:t> + 3つの臓器</a:t>
+              <a:t>3つの領域</a:t>
             </a:r>
             <a:endParaRPr lang="en-US" sz="3600" dirty="0"/>
           </a:p>
@@ -11457,7 +11417,7 @@
                 <a:ea typeface="Arial" pitchFamily="34" charset="-122"/>
                 <a:cs typeface="Arial" pitchFamily="34" charset="-120"/>
               </a:rPr>
-              <a:t>PHYSICAL</a:t>
+              <a:t>身体</a:t>
             </a:r>
             <a:endParaRPr lang="en-US" sz="1275" dirty="0"/>
           </a:p>
@@ -11502,7 +11462,7 @@
                 <a:ea typeface="Arial" pitchFamily="34" charset="-122"/>
                 <a:cs typeface="Arial" pitchFamily="34" charset="-120"/>
               </a:rPr>
-              <a:t>身体</a:t>
+              <a:t>健康</a:t>
             </a:r>
             <a:endParaRPr lang="en-US" sz="3150" dirty="0"/>
           </a:p>
@@ -11547,7 +11507,7 @@
                 <a:ea typeface="Arial" pitchFamily="34" charset="-122"/>
                 <a:cs typeface="Arial" pitchFamily="34" charset="-120"/>
               </a:rPr>
-              <a:t>未通院や未ケアを見つけ、生活圏と予定から予約する。</a:t>
+              <a:t>通院やケアの抜けを探し、空いている時間に予約する。</a:t>
             </a:r>
             <a:endParaRPr lang="en-US" sz="1800" dirty="0"/>
           </a:p>
@@ -11758,7 +11718,7 @@
                 <a:ea typeface="Arial" pitchFamily="34" charset="-122"/>
                 <a:cs typeface="Arial" pitchFamily="34" charset="-120"/>
               </a:rPr>
-              <a:t>MENTAL</a:t>
+              <a:t>心</a:t>
             </a:r>
             <a:endParaRPr lang="en-US" sz="1275" dirty="0"/>
           </a:p>
@@ -11803,7 +11763,7 @@
                 <a:ea typeface="Arial" pitchFamily="34" charset="-122"/>
                 <a:cs typeface="Arial" pitchFamily="34" charset="-120"/>
               </a:rPr>
-              <a:t>精神</a:t>
+              <a:t>気持ち</a:t>
             </a:r>
             <a:endParaRPr lang="en-US" sz="3150" dirty="0"/>
           </a:p>
@@ -11818,7 +11778,7 @@
         <p:spPr>
           <a:xfrm>
             <a:off x="4600575" y="3293864"/>
-            <a:ext cx="3050667" cy="959941"/>
+            <a:ext cx="3050667" cy="639961"/>
           </a:xfrm>
           <a:prstGeom prst="rect">
             <a:avLst/>
@@ -11848,7 +11808,7 @@
                 <a:ea typeface="Arial" pitchFamily="34" charset="-122"/>
                 <a:cs typeface="Arial" pitchFamily="34" charset="-120"/>
               </a:rPr>
-              <a:t>予定と場所から、効く瞬間に支援する。固定時刻ではない。</a:t>
+              <a:t>予定と場所を見て、必要になる直前に連絡する。</a:t>
             </a:r>
             <a:endParaRPr lang="en-US" sz="1800" dirty="0"/>
           </a:p>
@@ -11862,7 +11822,7 @@
         </p:nvSpPr>
         <p:spPr>
           <a:xfrm>
-            <a:off x="4600575" y="4501455"/>
+            <a:off x="4600575" y="4181475"/>
             <a:ext cx="3050667" cy="319980"/>
           </a:xfrm>
           <a:prstGeom prst="rect">
@@ -12059,7 +12019,7 @@
                 <a:ea typeface="Arial" pitchFamily="34" charset="-122"/>
                 <a:cs typeface="Arial" pitchFamily="34" charset="-120"/>
               </a:rPr>
-              <a:t>FINANCIAL</a:t>
+              <a:t>お金</a:t>
             </a:r>
             <a:endParaRPr lang="en-US" sz="1275" dirty="0"/>
           </a:p>
@@ -12104,7 +12064,7 @@
                 <a:ea typeface="Arial" pitchFamily="34" charset="-122"/>
                 <a:cs typeface="Arial" pitchFamily="34" charset="-120"/>
               </a:rPr>
-              <a:t>財務</a:t>
+              <a:t>収入</a:t>
             </a:r>
             <a:endParaRPr lang="en-US" sz="3150" dirty="0"/>
           </a:p>
@@ -12149,7 +12109,7 @@
                 <a:ea typeface="Arial" pitchFamily="34" charset="-122"/>
                 <a:cs typeface="Arial" pitchFamily="34" charset="-120"/>
               </a:rPr>
-              <a:t>AIが自分のwalletで稼ぎ、自分の計算資源を払い、余剰を送る。</a:t>
+              <a:t>AIが仕事で得た収入から、クラウド代を払い、残りを送る。</a:t>
             </a:r>
             <a:endParaRPr lang="en-US" sz="1800" dirty="0"/>
           </a:p>
@@ -12236,7 +12196,7 @@
                 <a:ea typeface="Arial" pitchFamily="34" charset="-122"/>
                 <a:cs typeface="Arial" pitchFamily="34" charset="-120"/>
               </a:rPr>
-              <a:t>頭脳：</a:t>
+              <a:t>判断：</a:t>
             </a:r>
             <a:pPr algn="ctr" indent="0" marL="0">
               <a:lnSpc>
@@ -12253,7 +12213,7 @@
                 <a:ea typeface="Arial" pitchFamily="34" charset="-122"/>
                 <a:cs typeface="Arial" pitchFamily="34" charset="-120"/>
               </a:rPr>
-              <a:t> intent-aware context graph ─ その人にとって重要な未処理を選ぶ</a:t>
+              <a:t>予定、場所、本人の希望を見て、次に片づける用事を決める</a:t>
             </a:r>
             <a:endParaRPr lang="en-US" sz="1800" dirty="0"/>
           </a:p>
@@ -12411,7 +12371,7 @@
                 <a:ea typeface="Arial" pitchFamily="34" charset="-122"/>
                 <a:cs typeface="Arial" pitchFamily="34" charset="-120"/>
               </a:rPr>
-              <a:t>HOW I BUILD</a:t>
+              <a:t>開発方法</a:t>
             </a:r>
             <a:endParaRPr lang="en-US" sz="1200" dirty="0"/>
           </a:p>
@@ -12456,7 +12416,7 @@
                 <a:ea typeface="Arial" pitchFamily="34" charset="-122"/>
                 <a:cs typeface="Arial" pitchFamily="34" charset="-120"/>
               </a:rPr>
-              <a:t>このシステムは、</a:t>
+              <a:t>開発の指示は、すべて</a:t>
             </a:r>
             <a:pPr algn="l" indent="0" marL="0">
               <a:lnSpc>
@@ -12476,27 +12436,7 @@
                 <a:ea typeface="Arial" pitchFamily="34" charset="-122"/>
                 <a:cs typeface="Arial" pitchFamily="34" charset="-120"/>
               </a:rPr>
-              <a:t>スマホだけで指揮</a:t>
-            </a:r>
-            <a:pPr algn="l" indent="0" marL="0">
-              <a:lnSpc>
-                <a:spcPts val="4104"/>
-              </a:lnSpc>
-              <a:spcBef>
-                <a:spcPts val="1050"/>
-              </a:spcBef>
-              <a:buNone/>
-            </a:pPr>
-            <a:r>
-              <a:rPr lang="en-US" sz="3600" dirty="0">
-                <a:solidFill>
-                  <a:srgbClr val="F7F4EA"/>
-                </a:solidFill>
-                <a:latin typeface="Arial" pitchFamily="34" charset="0"/>
-                <a:ea typeface="Arial" pitchFamily="34" charset="-122"/>
-                <a:cs typeface="Arial" pitchFamily="34" charset="-120"/>
-              </a:rPr>
-              <a:t>してつくっている</a:t>
+              <a:t>スマホから</a:t>
             </a:r>
             <a:endParaRPr lang="en-US" sz="3600" dirty="0"/>
           </a:p>
@@ -13024,7 +12964,7 @@
                 <a:ea typeface="Arial" pitchFamily="34" charset="-122"/>
                 <a:cs typeface="Arial" pitchFamily="34" charset="-120"/>
               </a:rPr>
-              <a:t>SOURCE OF TRUTH</a:t>
+              <a:t>記録</a:t>
             </a:r>
             <a:endParaRPr lang="en-US" sz="1275" dirty="0"/>
           </a:p>
@@ -13114,7 +13054,7 @@
                 <a:ea typeface="Arial" pitchFamily="34" charset="-122"/>
                 <a:cs typeface="Arial" pitchFamily="34" charset="-120"/>
               </a:rPr>
-              <a:t>spec・code・evidence</a:t>
+              <a:t>仕様・コード・実行結果</a:t>
             </a:r>
             <a:endParaRPr lang="en-US" sz="1800" dirty="0"/>
           </a:p>
@@ -13234,7 +13174,7 @@
                 <a:ea typeface="Arial" pitchFamily="34" charset="-122"/>
                 <a:cs typeface="Arial" pitchFamily="34" charset="-120"/>
               </a:rPr>
-              <a:t>PRODUCTION</a:t>
+              <a:t>本番</a:t>
             </a:r>
             <a:endParaRPr lang="en-US" sz="1275" dirty="0"/>
           </a:p>
@@ -13324,7 +13264,7 @@
                 <a:ea typeface="Arial" pitchFamily="34" charset="-122"/>
                 <a:cs typeface="Arial" pitchFamily="34" charset="-120"/>
               </a:rPr>
-              <a:t>常時稼働</a:t>
+              <a:t>いつでも動く</a:t>
             </a:r>
             <a:endParaRPr lang="en-US" sz="1800" dirty="0"/>
           </a:p>
@@ -13339,7 +13279,7 @@
         <p:spPr>
           <a:xfrm>
             <a:off x="2258378" y="5429250"/>
-            <a:ext cx="7675245" cy="373261"/>
+            <a:ext cx="7675245" cy="746522"/>
           </a:xfrm>
           <a:prstGeom prst="rect">
             <a:avLst/>
@@ -13366,7 +13306,7 @@
                 <a:ea typeface="Arial" pitchFamily="34" charset="-122"/>
                 <a:cs typeface="Arial" pitchFamily="34" charset="-120"/>
               </a:rPr>
-              <a:t>PCを操作するのではなく、</a:t>
+              <a:t>Mac miniにつないだCodexへ、</a:t>
             </a:r>
             <a:pPr algn="ctr" indent="0" marL="0">
               <a:lnSpc>
@@ -13383,7 +13323,7 @@
                 <a:ea typeface="Arial" pitchFamily="34" charset="-122"/>
                 <a:cs typeface="Arial" pitchFamily="34" charset="-120"/>
               </a:rPr>
-              <a:t>エージェントを運用する</a:t>
+              <a:t>ChatGPTアプリから話しかける</a:t>
             </a:r>
             <a:pPr algn="ctr" indent="0" marL="0">
               <a:lnSpc>
@@ -13558,7 +13498,7 @@
                 <a:ea typeface="Arial" pitchFamily="34" charset="-122"/>
                 <a:cs typeface="Arial" pitchFamily="34" charset="-120"/>
               </a:rPr>
-              <a:t>A DAY WITH LIFE MANAGER</a:t>
+              <a:t>毎日の使い方</a:t>
             </a:r>
             <a:endParaRPr lang="en-US" sz="1200" dirty="0"/>
           </a:p>
@@ -13603,7 +13543,7 @@
                 <a:ea typeface="Arial" pitchFamily="34" charset="-122"/>
                 <a:cs typeface="Arial" pitchFamily="34" charset="-120"/>
               </a:rPr>
-              <a:t>生活は「画面を開く」前に動く</a:t>
+              <a:t>予定を書いた後は、Life Managerが動く</a:t>
             </a:r>
             <a:endParaRPr lang="en-US" sz="3600" dirty="0"/>
           </a:p>
@@ -13782,7 +13722,7 @@
                 <a:ea typeface="Arial" pitchFamily="34" charset="-122"/>
                 <a:cs typeface="Arial" pitchFamily="34" charset="-120"/>
               </a:rPr>
-              <a:t>予定を書く</a:t>
+              <a:t>予定を入れる</a:t>
             </a:r>
             <a:endParaRPr lang="en-US" sz="1875" dirty="0"/>
           </a:p>
@@ -13827,7 +13767,7 @@
                 <a:ea typeface="Arial" pitchFamily="34" charset="-122"/>
                 <a:cs typeface="Arial" pitchFamily="34" charset="-120"/>
               </a:rPr>
-              <a:t>calendar</a:t>
+              <a:t>カレンダー</a:t>
             </a:r>
             <a:endParaRPr lang="en-US" sz="1275" dirty="0"/>
           </a:p>
@@ -13872,7 +13812,7 @@
                 <a:ea typeface="Arial" pitchFamily="34" charset="-122"/>
                 <a:cs typeface="Arial" pitchFamily="34" charset="-120"/>
               </a:rPr>
-              <a:t>予定を解釈</a:t>
+              <a:t>内容を読み取る</a:t>
             </a:r>
             <a:endParaRPr lang="en-US" sz="1800" dirty="0"/>
           </a:p>
@@ -13991,7 +13931,7 @@
                 <a:ea typeface="Arial" pitchFamily="34" charset="-122"/>
                 <a:cs typeface="Arial" pitchFamily="34" charset="-120"/>
               </a:rPr>
-              <a:t>移動を埋める</a:t>
+              <a:t>移動を追加</a:t>
             </a:r>
             <a:endParaRPr lang="en-US" sz="1875" dirty="0"/>
           </a:p>
@@ -14036,7 +13976,7 @@
                 <a:ea typeface="Arial" pitchFamily="34" charset="-122"/>
                 <a:cs typeface="Arial" pitchFamily="34" charset="-120"/>
               </a:rPr>
-              <a:t>travel</a:t>
+              <a:t>出発時刻</a:t>
             </a:r>
             <a:endParaRPr lang="en-US" sz="1275" dirty="0"/>
           </a:p>
@@ -14081,7 +14021,7 @@
                 <a:ea typeface="Arial" pitchFamily="34" charset="-122"/>
                 <a:cs typeface="Arial" pitchFamily="34" charset="-120"/>
               </a:rPr>
-              <a:t>起点から逆算</a:t>
+              <a:t>出発地から逆算</a:t>
             </a:r>
             <a:endParaRPr lang="en-US" sz="1800" dirty="0"/>
           </a:p>
@@ -14200,7 +14140,7 @@
                 <a:ea typeface="Arial" pitchFamily="34" charset="-122"/>
                 <a:cs typeface="Arial" pitchFamily="34" charset="-120"/>
               </a:rPr>
-              <a:t>電話が鳴る</a:t>
+              <a:t>電話で起こす</a:t>
             </a:r>
             <a:endParaRPr lang="en-US" sz="1875" dirty="0"/>
           </a:p>
@@ -14245,7 +14185,7 @@
                 <a:ea typeface="Arial" pitchFamily="34" charset="-122"/>
                 <a:cs typeface="Arial" pitchFamily="34" charset="-120"/>
               </a:rPr>
-              <a:t>T-10 / T-5</a:t>
+              <a:t>10分前・5分前</a:t>
             </a:r>
             <a:endParaRPr lang="en-US" sz="1275" dirty="0"/>
           </a:p>
@@ -14290,7 +14230,7 @@
                 <a:ea typeface="Arial" pitchFamily="34" charset="-122"/>
                 <a:cs typeface="Arial" pitchFamily="34" charset="-120"/>
               </a:rPr>
-              <a:t>出るまで促す</a:t>
+              <a:t>出るまで知らせる</a:t>
             </a:r>
             <a:endParaRPr lang="en-US" sz="1800" dirty="0"/>
           </a:p>
@@ -14454,7 +14394,7 @@
                 <a:ea typeface="Arial" pitchFamily="34" charset="-122"/>
                 <a:cs typeface="Arial" pitchFamily="34" charset="-120"/>
               </a:rPr>
-              <a:t>email</a:t>
+              <a:t>メール</a:t>
             </a:r>
             <a:endParaRPr lang="en-US" sz="1275" dirty="0"/>
           </a:p>
@@ -14499,7 +14439,7 @@
                 <a:ea typeface="Arial" pitchFamily="34" charset="-122"/>
                 <a:cs typeface="Arial" pitchFamily="34" charset="-120"/>
               </a:rPr>
-              <a:t>位置で確定後</a:t>
+              <a:t>位置を確認して送る</a:t>
             </a:r>
             <a:endParaRPr lang="en-US" sz="1800" dirty="0"/>
           </a:p>
@@ -14618,7 +14558,7 @@
                 <a:ea typeface="Arial" pitchFamily="34" charset="-122"/>
                 <a:cs typeface="Arial" pitchFamily="34" charset="-120"/>
               </a:rPr>
-              <a:t>事後報告</a:t>
+              <a:t>結果を知らせる</a:t>
             </a:r>
             <a:endParaRPr lang="en-US" sz="1875" dirty="0"/>
           </a:p>
@@ -14708,7 +14648,7 @@
                 <a:ea typeface="Arial" pitchFamily="34" charset="-122"/>
                 <a:cs typeface="Arial" pitchFamily="34" charset="-120"/>
               </a:rPr>
-              <a:t>聞かずに報告</a:t>
+              <a:t>終わった内容を報告</a:t>
             </a:r>
             <a:endParaRPr lang="en-US" sz="1800" dirty="0"/>
           </a:p>
@@ -14786,7 +14726,7 @@
                 <a:ea typeface="Arial" pitchFamily="34" charset="-122"/>
                 <a:cs typeface="Arial" pitchFamily="34" charset="-120"/>
               </a:rPr>
-              <a:t>主UIは </a:t>
+              <a:t>普段は </a:t>
             </a:r>
             <a:pPr algn="ctr" indent="0" marL="0">
               <a:lnSpc>
@@ -14803,7 +14743,7 @@
                 <a:ea typeface="Arial" pitchFamily="34" charset="-122"/>
                 <a:cs typeface="Arial" pitchFamily="34" charset="-120"/>
               </a:rPr>
-              <a:t>電話 + Telegram</a:t>
+              <a:t>電話とTelegram</a:t>
             </a:r>
             <a:pPr algn="ctr" indent="0" marL="0">
               <a:lnSpc>
@@ -14820,7 +14760,7 @@
                 <a:ea typeface="Arial" pitchFamily="34" charset="-122"/>
                 <a:cs typeface="Arial" pitchFamily="34" charset="-120"/>
               </a:rPr>
-              <a:t>。Webは許可・停止・証拠を見るコントロールパネル。</a:t>
+              <a:t>。Webは、許可、停止、実行結果の確認に使う。</a:t>
             </a:r>
             <a:endParaRPr lang="en-US" sz="1800" dirty="0"/>
           </a:p>
@@ -14978,7 +14918,7 @@
                 <a:ea typeface="Arial" pitchFamily="34" charset="-122"/>
                 <a:cs typeface="Arial" pitchFamily="34" charset="-120"/>
               </a:rPr>
-              <a:t>BUILT &amp; VERIFIED</a:t>
+              <a:t>現在地</a:t>
             </a:r>
             <a:endParaRPr lang="en-US" sz="1200" dirty="0"/>
           </a:p>
@@ -15015,15 +14955,15 @@
               <a:buNone/>
             </a:pPr>
             <a:r>
-              <a:rPr lang="en-US" sz="3600" dirty="0">
-                <a:solidFill>
-                  <a:srgbClr val="F7F4EA"/>
-                </a:solidFill>
-                <a:latin typeface="Arial" pitchFamily="34" charset="0"/>
-                <a:ea typeface="Arial" pitchFamily="34" charset="-122"/>
-                <a:cs typeface="Arial" pitchFamily="34" charset="-120"/>
-              </a:rPr>
-              <a:t>ここまでは、もう</a:t>
+              <a:rPr lang="en-US" sz="3600" b="1" dirty="0">
+                <a:solidFill>
+                  <a:srgbClr val="73D49C"/>
+                </a:solidFill>
+                <a:latin typeface="Arial" pitchFamily="34" charset="0"/>
+                <a:ea typeface="Arial" pitchFamily="34" charset="-122"/>
+                <a:cs typeface="Arial" pitchFamily="34" charset="-120"/>
+              </a:rPr>
+              <a:t>本番で動いている</a:t>
             </a:r>
             <a:pPr algn="l" indent="0" marL="0">
               <a:lnSpc>
@@ -15035,15 +14975,15 @@
               <a:buNone/>
             </a:pPr>
             <a:r>
-              <a:rPr lang="en-US" sz="3600" b="1" dirty="0">
-                <a:solidFill>
-                  <a:srgbClr val="73D49C"/>
-                </a:solidFill>
-                <a:latin typeface="Arial" pitchFamily="34" charset="0"/>
-                <a:ea typeface="Arial" pitchFamily="34" charset="-122"/>
-                <a:cs typeface="Arial" pitchFamily="34" charset="-120"/>
-              </a:rPr>
-              <a:t>動いている</a:t>
+              <a:rPr lang="en-US" sz="3600" dirty="0">
+                <a:solidFill>
+                  <a:srgbClr val="F7F4EA"/>
+                </a:solidFill>
+                <a:latin typeface="Arial" pitchFamily="34" charset="0"/>
+                <a:ea typeface="Arial" pitchFamily="34" charset="-122"/>
+                <a:cs typeface="Arial" pitchFamily="34" charset="-120"/>
+              </a:rPr>
+              <a:t>もの</a:t>
             </a:r>
             <a:endParaRPr lang="en-US" sz="3600" dirty="0"/>
           </a:p>
@@ -15239,7 +15179,7 @@
                 <a:ea typeface="Arial" pitchFamily="34" charset="-122"/>
                 <a:cs typeface="Arial" pitchFamily="34" charset="-120"/>
               </a:rPr>
-              <a:t>DAILY CORE</a:t>
+              <a:t>毎日の予定</a:t>
             </a:r>
             <a:endParaRPr lang="en-US" sz="1275" dirty="0"/>
           </a:p>
@@ -15284,7 +15224,7 @@
                 <a:ea typeface="Arial" pitchFamily="34" charset="-122"/>
                 <a:cs typeface="Arial" pitchFamily="34" charset="-120"/>
               </a:rPr>
-              <a:t>予定・travel・call・報告</a:t>
+              <a:t>予定・移動・電話・報告</a:t>
             </a:r>
             <a:endParaRPr lang="en-US" sz="1875" dirty="0"/>
           </a:p>
@@ -15329,7 +15269,7 @@
                 <a:ea typeface="Arial" pitchFamily="34" charset="-122"/>
                 <a:cs typeface="Arial" pitchFamily="34" charset="-120"/>
               </a:rPr>
-              <a:t>production依存 9/9</a:t>
+              <a:t>本番の依存先 9/9</a:t>
             </a:r>
             <a:endParaRPr lang="en-US" sz="1800" dirty="0"/>
           </a:p>
@@ -15495,7 +15435,7 @@
                 <a:ea typeface="Arial" pitchFamily="34" charset="-122"/>
                 <a:cs typeface="Arial" pitchFamily="34" charset="-120"/>
               </a:rPr>
-              <a:t>VOICE</a:t>
+              <a:t>電話</a:t>
             </a:r>
             <a:endParaRPr lang="en-US" sz="1275" dirty="0"/>
           </a:p>
@@ -15585,7 +15525,7 @@
                 <a:ea typeface="Arial" pitchFamily="34" charset="-122"/>
                 <a:cs typeface="Arial" pitchFamily="34" charset="-120"/>
               </a:rPr>
-              <a:t>実通話・録音</a:t>
+              <a:t>実際に通話・録音</a:t>
             </a:r>
             <a:endParaRPr lang="en-US" sz="1800" dirty="0"/>
           </a:p>
@@ -15751,7 +15691,7 @@
                 <a:ea typeface="Arial" pitchFamily="34" charset="-122"/>
                 <a:cs typeface="Arial" pitchFamily="34" charset="-120"/>
               </a:rPr>
-              <a:t>PANEL</a:t>
+              <a:t>個人パネル</a:t>
             </a:r>
             <a:endParaRPr lang="en-US" sz="1275" dirty="0"/>
           </a:p>
@@ -15796,7 +15736,7 @@
                 <a:ea typeface="Arial" pitchFamily="34" charset="-122"/>
                 <a:cs typeface="Arial" pitchFamily="34" charset="-120"/>
               </a:rPr>
-              <a:t>恒久 /panel + 個人session</a:t>
+              <a:t>/panel + 個人認証</a:t>
             </a:r>
             <a:endParaRPr lang="en-US" sz="1875" dirty="0"/>
           </a:p>
@@ -15841,7 +15781,7 @@
                 <a:ea typeface="Arial" pitchFamily="34" charset="-122"/>
                 <a:cs typeface="Arial" pitchFamily="34" charset="-120"/>
               </a:rPr>
-              <a:t>TG/Web 2入口</a:t>
+              <a:t>Telegram / Web</a:t>
             </a:r>
             <a:endParaRPr lang="en-US" sz="1800" dirty="0"/>
           </a:p>
@@ -16007,7 +15947,7 @@
                 <a:ea typeface="Arial" pitchFamily="34" charset="-122"/>
                 <a:cs typeface="Arial" pitchFamily="34" charset="-120"/>
               </a:rPr>
-              <a:t>CONTROL</a:t>
+              <a:t>設定</a:t>
             </a:r>
             <a:endParaRPr lang="en-US" sz="1275" dirty="0"/>
           </a:p>
@@ -16052,7 +15992,7 @@
                 <a:ea typeface="Arial" pitchFamily="34" charset="-122"/>
                 <a:cs typeface="Arial" pitchFamily="34" charset="-120"/>
               </a:rPr>
-              <a:t>接続・通知・call設定</a:t>
+              <a:t>接続・通知・電話</a:t>
             </a:r>
             <a:endParaRPr lang="en-US" sz="1875" dirty="0"/>
           </a:p>
@@ -16097,7 +16037,7 @@
                 <a:ea typeface="Arial" pitchFamily="34" charset="-122"/>
                 <a:cs typeface="Arial" pitchFamily="34" charset="-120"/>
               </a:rPr>
-              <a:t>chat/panel同一state</a:t>
+              <a:t>2画面で同じ状態</a:t>
             </a:r>
             <a:endParaRPr lang="en-US" sz="1800" dirty="0"/>
           </a:p>
@@ -16263,7 +16203,7 @@
                 <a:ea typeface="Arial" pitchFamily="34" charset="-122"/>
                 <a:cs typeface="Arial" pitchFamily="34" charset="-120"/>
               </a:rPr>
-              <a:t>SCORES</a:t>
+              <a:t>結果の集計</a:t>
             </a:r>
             <a:endParaRPr lang="en-US" sz="1275" dirty="0"/>
           </a:p>
@@ -16308,7 +16248,7 @@
                 <a:ea typeface="Arial" pitchFamily="34" charset="-122"/>
                 <a:cs typeface="Arial" pitchFamily="34" charset="-120"/>
               </a:rPr>
-              <a:t>4 organ outcome score</a:t>
+              <a:t>4領域の結果を集計</a:t>
             </a:r>
             <a:endParaRPr lang="en-US" sz="1875" dirty="0"/>
           </a:p>
@@ -16353,7 +16293,7 @@
                 <a:ea typeface="Arial" pitchFamily="34" charset="-122"/>
                 <a:cs typeface="Arial" pitchFamily="34" charset="-120"/>
               </a:rPr>
-              <a:t>0件は insufficient</a:t>
+              <a:t>対象0件も区別</a:t>
             </a:r>
             <a:endParaRPr lang="en-US" sz="1800" dirty="0"/>
           </a:p>
@@ -16519,7 +16459,7 @@
                 <a:ea typeface="Arial" pitchFamily="34" charset="-122"/>
                 <a:cs typeface="Arial" pitchFamily="34" charset="-120"/>
               </a:rPr>
-              <a:t>PRIVACY</a:t>
+              <a:t>画面の安全</a:t>
             </a:r>
             <a:endParaRPr lang="en-US" sz="1275" dirty="0"/>
           </a:p>
@@ -16564,7 +16504,7 @@
                 <a:ea typeface="Arial" pitchFamily="34" charset="-122"/>
                 <a:cs typeface="Arial" pitchFamily="34" charset="-120"/>
               </a:rPr>
-              <a:t>raw log・secret非表示</a:t>
+              <a:t>ログ・秘密情報を隠す</a:t>
             </a:r>
             <a:endParaRPr lang="en-US" sz="1875" dirty="0"/>
           </a:p>
@@ -16609,7 +16549,7 @@
                 <a:ea typeface="Arial" pitchFamily="34" charset="-122"/>
                 <a:cs typeface="Arial" pitchFamily="34" charset="-120"/>
               </a:rPr>
-              <a:t>mobile/desktop実証</a:t>
+              <a:t>スマホ / PCで確認</a:t>
             </a:r>
             <a:endParaRPr lang="en-US" sz="1800" dirty="0"/>
           </a:p>
@@ -16624,7 +16564,7 @@
         <p:spPr>
           <a:xfrm>
             <a:off x="685800" y="5810250"/>
-            <a:ext cx="3599593" cy="218480"/>
+            <a:ext cx="4228671" cy="218480"/>
           </a:xfrm>
           <a:prstGeom prst="rect">
             <a:avLst/>
@@ -16651,7 +16591,7 @@
                 <a:ea typeface="Arial" pitchFamily="34" charset="-122"/>
                 <a:cs typeface="Arial" pitchFamily="34" charset="-120"/>
               </a:rPr>
-              <a:t>L3 = 実世界のside effectを、実物のreceiptで確認</a:t>
+              <a:t>L3 = 本物の電話、メール、Message-IDなどで結果を確認</a:t>
             </a:r>
             <a:endParaRPr lang="en-US" sz="1275" dirty="0"/>
           </a:p>
@@ -16665,8 +16605,8 @@
         </p:nvSpPr>
         <p:spPr>
           <a:xfrm>
-            <a:off x="8977908" y="5810250"/>
-            <a:ext cx="2578858" cy="218480"/>
+            <a:off x="8537228" y="5810250"/>
+            <a:ext cx="3028352" cy="218480"/>
           </a:xfrm>
           <a:prstGeom prst="rect">
             <a:avLst/>
@@ -16693,7 +16633,7 @@
                 <a:ea typeface="Arial" pitchFamily="34" charset="-122"/>
                 <a:cs typeface="Arial" pitchFamily="34" charset="-120"/>
               </a:rPr>
-              <a:t>API 200だけでは「完了」にしない</a:t>
+              <a:t>APIが200を返しただけでは完了にしない</a:t>
             </a:r>
             <a:endParaRPr lang="en-US" sz="1275" dirty="0"/>
           </a:p>
@@ -16851,7 +16791,7 @@
                 <a:ea typeface="Arial" pitchFamily="34" charset="-122"/>
                 <a:cs typeface="Arial" pitchFamily="34" charset="-120"/>
               </a:rPr>
-              <a:t>ARCHITECTURE</a:t>
+              <a:t>仕組み</a:t>
             </a:r>
             <a:endParaRPr lang="en-US" sz="1200" dirty="0"/>
           </a:p>
@@ -16888,15 +16828,35 @@
               <a:buNone/>
             </a:pPr>
             <a:r>
+              <a:rPr lang="en-US" sz="3600" dirty="0">
+                <a:solidFill>
+                  <a:srgbClr val="F7F4EA"/>
+                </a:solidFill>
+                <a:latin typeface="Arial" pitchFamily="34" charset="0"/>
+                <a:ea typeface="Arial" pitchFamily="34" charset="-122"/>
+                <a:cs typeface="Arial" pitchFamily="34" charset="-120"/>
+              </a:rPr>
+              <a:t>Life Managerの</a:t>
+            </a:r>
+            <a:pPr algn="l" indent="0" marL="0">
+              <a:lnSpc>
+                <a:spcPts val="4104"/>
+              </a:lnSpc>
+              <a:spcBef>
+                <a:spcPts val="1050"/>
+              </a:spcBef>
+              <a:buNone/>
+            </a:pPr>
+            <a:r>
               <a:rPr lang="en-US" sz="3600" b="1" dirty="0">
                 <a:solidFill>
-                  <a:srgbClr val="F7F4EA"/>
-                </a:solidFill>
-                <a:latin typeface="Arial" pitchFamily="34" charset="0"/>
-                <a:ea typeface="Arial" pitchFamily="34" charset="-122"/>
-                <a:cs typeface="Arial" pitchFamily="34" charset="-120"/>
-              </a:rPr>
-              <a:t>1つの頭脳が、3つの臓器と外部世界を動かす</a:t>
+                  <a:srgbClr val="57D6C7"/>
+                </a:solidFill>
+                <a:latin typeface="Arial" pitchFamily="34" charset="0"/>
+                <a:ea typeface="Arial" pitchFamily="34" charset="-122"/>
+                <a:cs typeface="Arial" pitchFamily="34" charset="-120"/>
+              </a:rPr>
+              <a:t>処理の流れ</a:t>
             </a:r>
             <a:endParaRPr lang="en-US" sz="3600" dirty="0"/>
           </a:p>
@@ -17004,7 +16964,7 @@
                 <a:ea typeface="Arial" pitchFamily="34" charset="-122"/>
                 <a:cs typeface="Arial" pitchFamily="34" charset="-120"/>
               </a:rPr>
-              <a:t>BRAIN</a:t>
+              <a:t>判断に使う情報</a:t>
             </a:r>
             <a:endParaRPr lang="en-US" sz="1275" dirty="0"/>
           </a:p>
@@ -17049,7 +17009,7 @@
                 <a:ea typeface="Arial" pitchFamily="34" charset="-122"/>
                 <a:cs typeface="Arial" pitchFamily="34" charset="-120"/>
               </a:rPr>
-              <a:t>intent / context / consent / budget / evidence / ROI</a:t>
+              <a:t>本人の希望 / 予定 / 場所 / 許可 / 予算 / 過去の結果</a:t>
             </a:r>
             <a:endParaRPr lang="en-US" sz="1875" dirty="0"/>
           </a:p>
@@ -17127,7 +17087,7 @@
                 <a:ea typeface="Arial" pitchFamily="34" charset="-122"/>
                 <a:cs typeface="Arial" pitchFamily="34" charset="-120"/>
               </a:rPr>
-              <a:t>PHYSICAL</a:t>
+              <a:t>健康</a:t>
             </a:r>
             <a:endParaRPr lang="en-US" sz="1275" dirty="0"/>
           </a:p>
@@ -17250,7 +17210,7 @@
                 <a:ea typeface="Arial" pitchFamily="34" charset="-122"/>
                 <a:cs typeface="Arial" pitchFamily="34" charset="-120"/>
               </a:rPr>
-              <a:t>MENTAL</a:t>
+              <a:t>心</a:t>
             </a:r>
             <a:endParaRPr lang="en-US" sz="1275" dirty="0"/>
           </a:p>
@@ -17373,7 +17333,7 @@
                 <a:ea typeface="Arial" pitchFamily="34" charset="-122"/>
                 <a:cs typeface="Arial" pitchFamily="34" charset="-120"/>
               </a:rPr>
-              <a:t>FINANCIAL</a:t>
+              <a:t>お金</a:t>
             </a:r>
             <a:endParaRPr lang="en-US" sz="1275" dirty="0"/>
           </a:p>
@@ -17496,7 +17456,7 @@
                 <a:ea typeface="Arial" pitchFamily="34" charset="-122"/>
                 <a:cs typeface="Arial" pitchFamily="34" charset="-120"/>
               </a:rPr>
-              <a:t>RUNTIME</a:t>
+              <a:t>実行する手段</a:t>
             </a:r>
             <a:endParaRPr lang="en-US" sz="1275" dirty="0"/>
           </a:p>
@@ -17541,7 +17501,7 @@
                 <a:ea typeface="Arial" pitchFamily="34" charset="-122"/>
                 <a:cs typeface="Arial" pitchFamily="34" charset="-120"/>
               </a:rPr>
-              <a:t>scheduler / browser / email / voice / wallet / eval / ledger</a:t>
+              <a:t>定期実行 / ブラウザ / メール / 電話 / ウォレット / 評価 / 記録</a:t>
             </a:r>
             <a:endParaRPr lang="en-US" sz="1875" dirty="0"/>
           </a:p>
@@ -17741,8 +17701,8 @@
         </p:nvSpPr>
         <p:spPr>
           <a:xfrm>
-            <a:off x="5810548" y="5191125"/>
-            <a:ext cx="582171" cy="133350"/>
+            <a:off x="5769173" y="5191125"/>
+            <a:ext cx="666574" cy="133350"/>
           </a:xfrm>
           <a:prstGeom prst="rect">
             <a:avLst/>
@@ -17769,7 +17729,7 @@
                 <a:ea typeface="Arial" pitchFamily="34" charset="-122"/>
                 <a:cs typeface="Arial" pitchFamily="34" charset="-120"/>
               </a:rPr>
-              <a:t>Calendar</a:t>
+              <a:t>カレンダー</a:t>
             </a:r>
             <a:endParaRPr lang="en-US" sz="1050" dirty="0"/>
           </a:p>
@@ -17817,8 +17777,8 @@
         </p:nvSpPr>
         <p:spPr>
           <a:xfrm>
-            <a:off x="7547967" y="5191125"/>
-            <a:ext cx="760997" cy="133350"/>
+            <a:off x="7527727" y="5191125"/>
+            <a:ext cx="802136" cy="133350"/>
           </a:xfrm>
           <a:prstGeom prst="rect">
             <a:avLst/>
@@ -17845,7 +17805,7 @@
                 <a:ea typeface="Arial" pitchFamily="34" charset="-122"/>
                 <a:cs typeface="Arial" pitchFamily="34" charset="-120"/>
               </a:rPr>
-              <a:t>Email / Web</a:t>
+              <a:t>メール / Web</a:t>
             </a:r>
             <a:endParaRPr lang="en-US" sz="1050" dirty="0"/>
           </a:p>
@@ -17893,8 +17853,8 @@
         </p:nvSpPr>
         <p:spPr>
           <a:xfrm>
-            <a:off x="9568011" y="5191125"/>
-            <a:ext cx="362965" cy="133350"/>
+            <a:off x="9412635" y="5191125"/>
+            <a:ext cx="680085" cy="133350"/>
           </a:xfrm>
           <a:prstGeom prst="rect">
             <a:avLst/>
@@ -17921,7 +17881,7 @@
                 <a:ea typeface="Arial" pitchFamily="34" charset="-122"/>
                 <a:cs typeface="Arial" pitchFamily="34" charset="-120"/>
               </a:rPr>
-              <a:t>Panel</a:t>
+              <a:t>個人パネル</a:t>
             </a:r>
             <a:endParaRPr lang="en-US" sz="1050" dirty="0"/>
           </a:p>
@@ -18079,7 +18039,7 @@
                 <a:ea typeface="Arial" pitchFamily="34" charset="-122"/>
                 <a:cs typeface="Arial" pitchFamily="34" charset="-120"/>
               </a:rPr>
-              <a:t>UX PRINCIPLE</a:t>
+              <a:t>使う画面</a:t>
             </a:r>
             <a:endParaRPr lang="en-US" sz="1200" dirty="0"/>
           </a:p>
@@ -18124,7 +18084,7 @@
                 <a:ea typeface="Arial" pitchFamily="34" charset="-122"/>
                 <a:cs typeface="Arial" pitchFamily="34" charset="-120"/>
               </a:rPr>
-              <a:t>行動は向こうから。設定と証拠は</a:t>
+              <a:t>本人への連絡と、</a:t>
             </a:r>
             <a:pPr algn="l" indent="0" marL="0">
               <a:lnSpc>
@@ -18144,27 +18104,7 @@
                 <a:ea typeface="Arial" pitchFamily="34" charset="-122"/>
                 <a:cs typeface="Arial" pitchFamily="34" charset="-120"/>
               </a:rPr>
-              <a:t>1枚の鏡</a:t>
-            </a:r>
-            <a:pPr algn="l" indent="0" marL="0">
-              <a:lnSpc>
-                <a:spcPts val="4104"/>
-              </a:lnSpc>
-              <a:spcBef>
-                <a:spcPts val="1050"/>
-              </a:spcBef>
-              <a:buNone/>
-            </a:pPr>
-            <a:r>
-              <a:rPr lang="en-US" sz="3600" dirty="0">
-                <a:solidFill>
-                  <a:srgbClr val="F7F4EA"/>
-                </a:solidFill>
-                <a:latin typeface="Arial" pitchFamily="34" charset="0"/>
-                <a:ea typeface="Arial" pitchFamily="34" charset="-122"/>
-                <a:cs typeface="Arial" pitchFamily="34" charset="-120"/>
-              </a:rPr>
-              <a:t>に。</a:t>
+              <a:t>確認画面</a:t>
             </a:r>
             <a:endParaRPr lang="en-US" sz="3600" dirty="0"/>
           </a:p>
@@ -18272,7 +18212,7 @@
                 <a:ea typeface="Arial" pitchFamily="34" charset="-122"/>
                 <a:cs typeface="Arial" pitchFamily="34" charset="-120"/>
               </a:rPr>
-              <a:t>AMBIENT CHANNELS</a:t>
+              <a:t>ふだん使う</a:t>
             </a:r>
             <a:endParaRPr lang="en-US" sz="1275" dirty="0"/>
           </a:p>
@@ -18377,7 +18317,7 @@
         <p:spPr>
           <a:xfrm>
             <a:off x="1019175" y="4352925"/>
-            <a:ext cx="1196280" cy="304800"/>
+            <a:ext cx="1333500" cy="304800"/>
           </a:xfrm>
           <a:prstGeom prst="roundRect">
             <a:avLst>
@@ -18411,7 +18351,7 @@
         <p:spPr>
           <a:xfrm>
             <a:off x="1152525" y="4438650"/>
-            <a:ext cx="948172" cy="133350"/>
+            <a:ext cx="1088136" cy="133350"/>
           </a:xfrm>
           <a:prstGeom prst="rect">
             <a:avLst/>
@@ -18438,7 +18378,7 @@
                 <a:ea typeface="Arial" pitchFamily="34" charset="-122"/>
                 <a:cs typeface="Arial" pitchFamily="34" charset="-120"/>
               </a:rPr>
-              <a:t>向こうから来る</a:t>
+              <a:t>必要なときに届く</a:t>
             </a:r>
             <a:endParaRPr lang="en-US" sz="1050" dirty="0"/>
           </a:p>
@@ -18489,7 +18429,7 @@
         <p:spPr>
           <a:xfrm>
             <a:off x="5343525" y="2219325"/>
-            <a:ext cx="2315932" cy="218480"/>
+            <a:ext cx="1020279" cy="218480"/>
           </a:xfrm>
           <a:prstGeom prst="rect">
             <a:avLst/>
@@ -18516,7 +18456,7 @@
                 <a:ea typeface="Arial" pitchFamily="34" charset="-122"/>
                 <a:cs typeface="Arial" pitchFamily="34" charset="-120"/>
               </a:rPr>
-              <a:t>PERSONAL CONTROL PANEL</a:t>
+              <a:t>確認と設定</a:t>
             </a:r>
             <a:endParaRPr lang="en-US" sz="1275" dirty="0"/>
           </a:p>
@@ -18531,7 +18471,7 @@
         <p:spPr>
           <a:xfrm>
             <a:off x="5343525" y="2571155"/>
-            <a:ext cx="2315932" cy="412552"/>
+            <a:ext cx="1020279" cy="412552"/>
           </a:xfrm>
           <a:prstGeom prst="rect">
             <a:avLst/>
@@ -18575,8 +18515,8 @@
         </p:nvSpPr>
         <p:spPr>
           <a:xfrm>
-            <a:off x="10009584" y="2449116"/>
-            <a:ext cx="1163241" cy="304800"/>
+            <a:off x="10239375" y="2449116"/>
+            <a:ext cx="933450" cy="304800"/>
           </a:xfrm>
           <a:prstGeom prst="roundRect">
             <a:avLst>
@@ -18609,8 +18549,8 @@
         </p:nvSpPr>
         <p:spPr>
           <a:xfrm>
-            <a:off x="10142934" y="2534841"/>
-            <a:ext cx="914471" cy="133350"/>
+            <a:off x="10372725" y="2534841"/>
+            <a:ext cx="680085" cy="133350"/>
           </a:xfrm>
           <a:prstGeom prst="rect">
             <a:avLst/>
@@ -18637,7 +18577,7 @@
                 <a:ea typeface="Arial" pitchFamily="34" charset="-122"/>
                 <a:cs typeface="Arial" pitchFamily="34" charset="-120"/>
               </a:rPr>
-              <a:t>PRODUCTION</a:t>
+              <a:t>本番稼働中</a:t>
             </a:r>
             <a:endParaRPr lang="en-US" sz="1050" dirty="0"/>
           </a:p>
@@ -18715,7 +18655,7 @@
                 <a:ea typeface="Arial" pitchFamily="34" charset="-122"/>
                 <a:cs typeface="Arial" pitchFamily="34" charset="-120"/>
               </a:rPr>
-              <a:t>今日のtimeline</a:t>
+              <a:t>今日の予定</a:t>
             </a:r>
             <a:endParaRPr lang="en-US" sz="1275" dirty="0"/>
           </a:p>
@@ -18793,7 +18733,7 @@
                 <a:ea typeface="Arial" pitchFamily="34" charset="-122"/>
                 <a:cs typeface="Arial" pitchFamily="34" charset="-120"/>
               </a:rPr>
-              <a:t>3 organ score</a:t>
+              <a:t>3領域の結果</a:t>
             </a:r>
             <a:endParaRPr lang="en-US" sz="1275" dirty="0"/>
           </a:p>
@@ -18871,7 +18811,7 @@
                 <a:ea typeface="Arial" pitchFamily="34" charset="-122"/>
                 <a:cs typeface="Arial" pitchFamily="34" charset="-120"/>
               </a:rPr>
-              <a:t>収益・送金台帳</a:t>
+              <a:t>収益と送金</a:t>
             </a:r>
             <a:endParaRPr lang="en-US" sz="1275" dirty="0"/>
           </a:p>
@@ -18949,7 +18889,7 @@
                 <a:ea typeface="Arial" pitchFamily="34" charset="-122"/>
                 <a:cs typeface="Arial" pitchFamily="34" charset="-120"/>
               </a:rPr>
-              <a:t>context gate</a:t>
+              <a:t>判断に使った情報</a:t>
             </a:r>
             <a:endParaRPr lang="en-US" sz="1275" dirty="0"/>
           </a:p>
@@ -19105,7 +19045,7 @@
                 <a:ea typeface="Arial" pitchFamily="34" charset="-122"/>
                 <a:cs typeface="Arial" pitchFamily="34" charset="-120"/>
               </a:rPr>
-              <a:t>停止・ON/OFF</a:t>
+              <a:t>停止と再開</a:t>
             </a:r>
             <a:endParaRPr lang="en-US" sz="1275" dirty="0"/>
           </a:p>
@@ -19263,7 +19203,7 @@
                 <a:ea typeface="Arial" pitchFamily="34" charset="-122"/>
                 <a:cs typeface="Arial" pitchFamily="34" charset="-120"/>
               </a:rPr>
-              <a:t>SELF-IMPROVING / SELF-HEALING</a:t>
+              <a:t>自動修復</a:t>
             </a:r>
             <a:endParaRPr lang="en-US" sz="1200" dirty="0"/>
           </a:p>
@@ -19308,7 +19248,7 @@
                 <a:ea typeface="Arial" pitchFamily="34" charset="-122"/>
                 <a:cs typeface="Arial" pitchFamily="34" charset="-120"/>
               </a:rPr>
-              <a:t>人間がログを見る仕事を、</a:t>
+              <a:t>失敗を見つけて、直し、</a:t>
             </a:r>
             <a:pPr algn="l" indent="0" marL="0">
               <a:lnSpc>
@@ -19328,7 +19268,7 @@
                 <a:ea typeface="Arial" pitchFamily="34" charset="-122"/>
                 <a:cs typeface="Arial" pitchFamily="34" charset="-120"/>
               </a:rPr>
-              <a:t>ループに返す</a:t>
+              <a:t>次を防ぐ</a:t>
             </a:r>
             <a:endParaRPr lang="en-US" sz="3600" dirty="0"/>
           </a:p>
@@ -19526,7 +19466,7 @@
                 <a:ea typeface="Arial" pitchFamily="34" charset="-122"/>
                 <a:cs typeface="Arial" pitchFamily="34" charset="-120"/>
               </a:rPr>
-              <a:t>log / metric</a:t>
+              <a:t>ログ・数値</a:t>
             </a:r>
             <a:endParaRPr lang="en-US" sz="1275" dirty="0"/>
           </a:p>
@@ -19691,7 +19631,7 @@
                 <a:ea typeface="Arial" pitchFamily="34" charset="-122"/>
                 <a:cs typeface="Arial" pitchFamily="34" charset="-120"/>
               </a:rPr>
-              <a:t>評価</a:t>
+              <a:t>判定</a:t>
             </a:r>
             <a:endParaRPr lang="en-US" sz="2100" dirty="0"/>
           </a:p>
@@ -19736,7 +19676,7 @@
                 <a:ea typeface="Arial" pitchFamily="34" charset="-122"/>
                 <a:cs typeface="Arial" pitchFamily="34" charset="-120"/>
               </a:rPr>
-              <a:t>eval / judge</a:t>
+              <a:t>合格 / 失敗</a:t>
             </a:r>
             <a:endParaRPr lang="en-US" sz="1275" dirty="0"/>
           </a:p>
@@ -19901,7 +19841,7 @@
                 <a:ea typeface="Arial" pitchFamily="34" charset="-122"/>
                 <a:cs typeface="Arial" pitchFamily="34" charset="-120"/>
               </a:rPr>
-              <a:t>行動</a:t>
+              <a:t>修正</a:t>
             </a:r>
             <a:endParaRPr lang="en-US" sz="2100" dirty="0"/>
           </a:p>
@@ -19946,7 +19886,7 @@
                 <a:ea typeface="Arial" pitchFamily="34" charset="-122"/>
                 <a:cs typeface="Arial" pitchFamily="34" charset="-120"/>
               </a:rPr>
-              <a:t>tool / PR</a:t>
+              <a:t>コード・PR</a:t>
             </a:r>
             <a:endParaRPr lang="en-US" sz="1275" dirty="0"/>
           </a:p>
@@ -20111,7 +20051,7 @@
                 <a:ea typeface="Arial" pitchFamily="34" charset="-122"/>
                 <a:cs typeface="Arial" pitchFamily="34" charset="-120"/>
               </a:rPr>
-              <a:t>実証</a:t>
+              <a:t>確認</a:t>
             </a:r>
             <a:endParaRPr lang="en-US" sz="2100" dirty="0"/>
           </a:p>
@@ -20156,7 +20096,7 @@
                 <a:ea typeface="Arial" pitchFamily="34" charset="-122"/>
                 <a:cs typeface="Arial" pitchFamily="34" charset="-120"/>
               </a:rPr>
-              <a:t>receipt / E2E</a:t>
+              <a:t>実物で試す</a:t>
             </a:r>
             <a:endParaRPr lang="en-US" sz="1275" dirty="0"/>
           </a:p>
@@ -20321,7 +20261,7 @@
                 <a:ea typeface="Arial" pitchFamily="34" charset="-122"/>
                 <a:cs typeface="Arial" pitchFamily="34" charset="-120"/>
               </a:rPr>
-              <a:t>学習</a:t>
+              <a:t>再発防止</a:t>
             </a:r>
             <a:endParaRPr lang="en-US" sz="2100" dirty="0"/>
           </a:p>
@@ -20366,7 +20306,7 @@
                 <a:ea typeface="Arial" pitchFamily="34" charset="-122"/>
                 <a:cs typeface="Arial" pitchFamily="34" charset="-120"/>
               </a:rPr>
-              <a:t>lesson / test</a:t>
+              <a:t>テストに残す</a:t>
             </a:r>
             <a:endParaRPr lang="en-US" sz="1275" dirty="0"/>
           </a:p>
@@ -20416,8 +20356,8 @@
         </p:nvSpPr>
         <p:spPr>
           <a:xfrm>
-            <a:off x="2085975" y="5307360"/>
-            <a:ext cx="1165860" cy="319980"/>
+            <a:off x="2085975" y="5147370"/>
+            <a:ext cx="1072348" cy="639961"/>
           </a:xfrm>
           <a:prstGeom prst="rect">
             <a:avLst/>
@@ -20458,8 +20398,8 @@
         </p:nvSpPr>
         <p:spPr>
           <a:xfrm>
-            <a:off x="3882479" y="5307360"/>
-            <a:ext cx="6348017" cy="319980"/>
+            <a:off x="3137297" y="5147370"/>
+            <a:ext cx="7108103" cy="639961"/>
           </a:xfrm>
           <a:prstGeom prst="rect">
             <a:avLst/>
@@ -20486,7 +20426,7 @@
                 <a:ea typeface="Arial" pitchFamily="34" charset="-122"/>
                 <a:cs typeface="Arial" pitchFamily="34" charset="-120"/>
               </a:rPr>
-              <a:t>exit 0にしない → 原因を特定 → testへ固定 → 修復 → 再実証</a:t>
+              <a:t>成功扱いしない → 原因を探す → テストを追加 → 修正 → もう一度動かす</a:t>
             </a:r>
             <a:endParaRPr lang="en-US" sz="1800" dirty="0"/>
           </a:p>

</xml_diff>